<commit_message>
PPT v2.2 升级: 加 slide-27(3 防御位 × 12 构型) + 品牌水印
</commit_message>
<xml_diff>
--- a/03-培训PPT/attachment-enneagram-consultation-training.pptx
+++ b/03-培训PPT/attachment-enneagram-consultation-training.pptx
@@ -31,9 +31,10 @@
     <p:sldId id="279" r:id="rId25"/>
     <p:sldId id="280" r:id="rId26"/>
     <p:sldId id="281" r:id="rId27"/>
+    <p:sldId id="282" r:id="rId28"/>
   </p:sldIdLst>
   <p:notesMasterIdLst>
-    <p:notesMasterId r:id="rId28"/>
+    <p:notesMasterId r:id="rId29"/>
   </p:notesMasterIdLst>
   <p:sldSz cx="9144000" cy="5143500"/>
   <p:notesSz cx="5143500" cy="9144000"/>
@@ -2135,6 +2136,94 @@
             <a:fld id="{F7021451-1387-4CA6-816F-3879F97B5CBC}" type="slidenum">
               <a:rPr lang="en-US"/>
               <a:t>26</a:t>
+            </a:fld>
+            <a:endParaRPr lang="en-US"/>
+          </a:p>
+        </p:txBody>
+      </p:sp>
+    </p:spTree>
+    <p:extLst>
+      <p:ext uri="{BB962C8B-B14F-4D97-AF65-F5344CB8AC3E}">
+        <p14:creationId xmlns:p14="http://schemas.microsoft.com/office/powerpoint/2010/main" val="1024086991"/>
+      </p:ext>
+    </p:extLst>
+  </p:cSld>
+  <p:clrMapOvr>
+    <a:masterClrMapping/>
+  </p:clrMapOvr>
+</p:notes>
+</file>
+
+<file path=ppt/notesSlides/notesSlide27.xml><?xml version="1.0" encoding="utf-8"?>
+<p:notes xmlns:a="http://schemas.openxmlformats.org/drawingml/2006/main" xmlns:r="http://schemas.openxmlformats.org/officeDocument/2006/relationships" xmlns:p="http://schemas.openxmlformats.org/presentationml/2006/main">
+  <p:cSld>
+    <p:spTree>
+      <p:nvGrpSpPr>
+        <p:cNvPr id="1" name=""/>
+        <p:cNvGrpSpPr/>
+        <p:nvPr/>
+      </p:nvGrpSpPr>
+      <p:grpSpPr>
+        <a:xfrm>
+          <a:off x="0" y="0"/>
+          <a:ext cx="0" cy="0"/>
+          <a:chOff x="0" y="0"/>
+          <a:chExt cx="0" cy="0"/>
+        </a:xfrm>
+      </p:grpSpPr>
+      <p:sp>
+        <p:nvSpPr>
+          <p:cNvPr id="2" name="Slide Image Placeholder 1"/>
+          <p:cNvSpPr>
+            <a:spLocks noGrp="1" noRot="1" noChangeAspect="1"/>
+          </p:cNvSpPr>
+          <p:nvPr>
+            <p:ph type="sldImg"/>
+          </p:nvPr>
+        </p:nvSpPr>
+        <p:spPr/>
+      </p:sp>
+      <p:sp>
+        <p:nvSpPr>
+          <p:cNvPr id="3" name="Notes Placeholder 2"/>
+          <p:cNvSpPr>
+            <a:spLocks noGrp="1"/>
+          </p:cNvSpPr>
+          <p:nvPr>
+            <p:ph type="body" idx="1"/>
+          </p:nvPr>
+        </p:nvSpPr>
+        <p:spPr/>
+        <p:txBody>
+          <a:bodyPr/>
+          <a:lstStyle/>
+          <a:p>
+            <a:r>
+              <a:rPr lang="en-US" dirty="0"/>
+              <a:t/>
+            </a:r>
+            <a:endParaRPr lang="en-US" dirty="0"/>
+          </a:p>
+        </p:txBody>
+      </p:sp>
+      <p:sp>
+        <p:nvSpPr>
+          <p:cNvPr id="4" name="Slide Number Placeholder 3"/>
+          <p:cNvSpPr>
+            <a:spLocks noGrp="1"/>
+          </p:cNvSpPr>
+          <p:nvPr>
+            <p:ph type="sldNum" sz="quarter" idx="10"/>
+          </p:nvPr>
+        </p:nvSpPr>
+        <p:spPr/>
+        <p:txBody>
+          <a:bodyPr/>
+          <a:lstStyle/>
+          <a:p>
+            <a:fld id="{F7021451-1387-4CA6-816F-3879F97B5CBC}" type="slidenum">
+              <a:rPr lang="en-US"/>
+              <a:t>27</a:t>
             </a:fld>
             <a:endParaRPr lang="en-US"/>
           </a:p>
@@ -8066,6 +8155,45 @@
           </a:p>
         </p:txBody>
       </p:sp>
+      <p:sp>
+        <p:nvSpPr>
+          <p:cNvPr id="8" name="Text 5"/>
+          <p:cNvSpPr/>
+          <p:nvPr/>
+        </p:nvSpPr>
+        <p:spPr>
+          <a:xfrm>
+            <a:off x="5943600" y="4892040"/>
+            <a:ext cx="2743200" cy="228600"/>
+          </a:xfrm>
+          <a:prstGeom prst="rect">
+            <a:avLst/>
+          </a:prstGeom>
+          <a:noFill/>
+          <a:ln/>
+        </p:spPr>
+        <p:txBody>
+          <a:bodyPr wrap="square" rtlCol="0" anchor="ctr"/>
+          <a:lstStyle/>
+          <a:p>
+            <a:pPr algn="r" indent="0" marL="0">
+              <a:buNone/>
+            </a:pPr>
+            <a:r>
+              <a:rPr lang="en-US" sz="900" dirty="0">
+                <a:solidFill>
+                  <a:srgbClr val="E2725B"/>
+                </a:solidFill>
+                <a:latin typeface="Microsoft YaHei" pitchFamily="34" charset="0"/>
+                <a:ea typeface="Microsoft YaHei" pitchFamily="34" charset="-122"/>
+                <a:cs typeface="Microsoft YaHei" pitchFamily="34" charset="-120"/>
+              </a:rPr>
+              <a:t>一念三轴 · Yiinian Triaxis (v2.2)</a:t>
+            </a:r>
+            <a:endParaRPr lang="en-US" sz="900" dirty="0"/>
+          </a:p>
+        </p:txBody>
+      </p:sp>
     </p:spTree>
   </p:cSld>
   <p:clrMapOvr>
@@ -9202,6 +9330,45 @@
               <a:t>14</a:t>
             </a:r>
             <a:endParaRPr lang="en-US" sz="1000" dirty="0"/>
+          </a:p>
+        </p:txBody>
+      </p:sp>
+      <p:sp>
+        <p:nvSpPr>
+          <p:cNvPr id="35" name="Text 33"/>
+          <p:cNvSpPr/>
+          <p:nvPr/>
+        </p:nvSpPr>
+        <p:spPr>
+          <a:xfrm>
+            <a:off x="5943600" y="4892040"/>
+            <a:ext cx="2743200" cy="228600"/>
+          </a:xfrm>
+          <a:prstGeom prst="rect">
+            <a:avLst/>
+          </a:prstGeom>
+          <a:noFill/>
+          <a:ln/>
+        </p:spPr>
+        <p:txBody>
+          <a:bodyPr wrap="square" rtlCol="0" anchor="ctr"/>
+          <a:lstStyle/>
+          <a:p>
+            <a:pPr algn="r" indent="0" marL="0">
+              <a:buNone/>
+            </a:pPr>
+            <a:r>
+              <a:rPr lang="en-US" sz="900" dirty="0">
+                <a:solidFill>
+                  <a:srgbClr val="E2725B"/>
+                </a:solidFill>
+                <a:latin typeface="Microsoft YaHei" pitchFamily="34" charset="0"/>
+                <a:ea typeface="Microsoft YaHei" pitchFamily="34" charset="-122"/>
+                <a:cs typeface="Microsoft YaHei" pitchFamily="34" charset="-120"/>
+              </a:rPr>
+              <a:t>一念三轴 · Yiinian Triaxis (v2.2)</a:t>
+            </a:r>
+            <a:endParaRPr lang="en-US" sz="900" dirty="0"/>
           </a:p>
         </p:txBody>
       </p:sp>
@@ -10899,6 +11066,45 @@
           </a:p>
         </p:txBody>
       </p:sp>
+      <p:sp>
+        <p:nvSpPr>
+          <p:cNvPr id="8" name="Text 5"/>
+          <p:cNvSpPr/>
+          <p:nvPr/>
+        </p:nvSpPr>
+        <p:spPr>
+          <a:xfrm>
+            <a:off x="5943600" y="4892040"/>
+            <a:ext cx="2743200" cy="228600"/>
+          </a:xfrm>
+          <a:prstGeom prst="rect">
+            <a:avLst/>
+          </a:prstGeom>
+          <a:noFill/>
+          <a:ln/>
+        </p:spPr>
+        <p:txBody>
+          <a:bodyPr wrap="square" rtlCol="0" anchor="ctr"/>
+          <a:lstStyle/>
+          <a:p>
+            <a:pPr algn="r" indent="0" marL="0">
+              <a:buNone/>
+            </a:pPr>
+            <a:r>
+              <a:rPr lang="en-US" sz="900" dirty="0">
+                <a:solidFill>
+                  <a:srgbClr val="E2725B"/>
+                </a:solidFill>
+                <a:latin typeface="Microsoft YaHei" pitchFamily="34" charset="0"/>
+                <a:ea typeface="Microsoft YaHei" pitchFamily="34" charset="-122"/>
+                <a:cs typeface="Microsoft YaHei" pitchFamily="34" charset="-120"/>
+              </a:rPr>
+              <a:t>一念三轴 · Yiinian Triaxis (v2.2)</a:t>
+            </a:r>
+            <a:endParaRPr lang="en-US" sz="900" dirty="0"/>
+          </a:p>
+        </p:txBody>
+      </p:sp>
     </p:spTree>
   </p:cSld>
   <p:clrMapOvr>
@@ -11081,7 +11287,7 @@
                 <a:ea typeface="Microsoft YaHei" pitchFamily="34" charset="-122"/>
                 <a:cs typeface="Microsoft YaHei" pitchFamily="34" charset="-120"/>
               </a:rPr>
-              <a:t>五阶段流程 + 核心干预技术</a:t>
+              <a:t>6 阶段三轴递进路径 · 11 核心技术</a:t>
             </a:r>
             <a:endParaRPr lang="en-US" sz="1400" dirty="0"/>
           </a:p>
@@ -11143,6 +11349,45 @@
               <a:t>16</a:t>
             </a:r>
             <a:endParaRPr lang="en-US" sz="1000" dirty="0"/>
+          </a:p>
+        </p:txBody>
+      </p:sp>
+      <p:sp>
+        <p:nvSpPr>
+          <p:cNvPr id="8" name="Text 6"/>
+          <p:cNvSpPr/>
+          <p:nvPr/>
+        </p:nvSpPr>
+        <p:spPr>
+          <a:xfrm>
+            <a:off x="5943600" y="4892040"/>
+            <a:ext cx="2743200" cy="228600"/>
+          </a:xfrm>
+          <a:prstGeom prst="rect">
+            <a:avLst/>
+          </a:prstGeom>
+          <a:noFill/>
+          <a:ln/>
+        </p:spPr>
+        <p:txBody>
+          <a:bodyPr wrap="square" rtlCol="0" anchor="ctr"/>
+          <a:lstStyle/>
+          <a:p>
+            <a:pPr algn="r" indent="0" marL="0">
+              <a:buNone/>
+            </a:pPr>
+            <a:r>
+              <a:rPr lang="en-US" sz="900" dirty="0">
+                <a:solidFill>
+                  <a:srgbClr val="E2725B"/>
+                </a:solidFill>
+                <a:latin typeface="Microsoft YaHei" pitchFamily="34" charset="0"/>
+                <a:ea typeface="Microsoft YaHei" pitchFamily="34" charset="-122"/>
+                <a:cs typeface="Microsoft YaHei" pitchFamily="34" charset="-120"/>
+              </a:rPr>
+              <a:t>一念三轴 · Yiinian Triaxis (v2.2)</a:t>
+            </a:r>
+            <a:endParaRPr lang="en-US" sz="900" dirty="0"/>
           </a:p>
         </p:txBody>
       </p:sp>
@@ -11211,7 +11456,7 @@
                 <a:ea typeface="Microsoft YaHei" pitchFamily="34" charset="-122"/>
                 <a:cs typeface="Microsoft YaHei" pitchFamily="34" charset="-120"/>
               </a:rPr>
-              <a:t>五阶段咨询流程</a:t>
+              <a:t>6 阶段三轴递进路径</a:t>
             </a:r>
             <a:endParaRPr lang="en-US" sz="3000" dirty="0"/>
           </a:p>
@@ -11250,7 +11495,7 @@
                 <a:ea typeface="Arial" pitchFamily="34" charset="-122"/>
                 <a:cs typeface="Arial" pitchFamily="34" charset="-120"/>
               </a:rPr>
-              <a:t>Five-Stage Consultation Process</a:t>
+              <a:t>Six-Stage Tri-Axis Progressive Path</a:t>
             </a:r>
             <a:endParaRPr lang="en-US" sz="1200" dirty="0"/>
           </a:p>
@@ -11264,8 +11509,8 @@
         </p:nvSpPr>
         <p:spPr>
           <a:xfrm>
-            <a:off x="457200" y="1554480"/>
-            <a:ext cx="1600200" cy="2743200"/>
+            <a:off x="365760" y="1554480"/>
+            <a:ext cx="1325880" cy="2926080"/>
           </a:xfrm>
           <a:prstGeom prst="rect">
             <a:avLst/>
@@ -11289,8 +11534,8 @@
         </p:nvSpPr>
         <p:spPr>
           <a:xfrm>
-            <a:off x="457200" y="1554480"/>
-            <a:ext cx="1600200" cy="365760"/>
+            <a:off x="365760" y="1554480"/>
+            <a:ext cx="1325880" cy="365760"/>
           </a:xfrm>
           <a:prstGeom prst="rect">
             <a:avLst/>
@@ -11309,8 +11554,8 @@
         </p:nvSpPr>
         <p:spPr>
           <a:xfrm>
-            <a:off x="457200" y="1600200"/>
-            <a:ext cx="1600200" cy="274320"/>
+            <a:off x="365760" y="1600200"/>
+            <a:ext cx="1325880" cy="274320"/>
           </a:xfrm>
           <a:prstGeom prst="rect">
             <a:avLst/>
@@ -11348,8 +11593,128 @@
         </p:nvSpPr>
         <p:spPr>
           <a:xfrm>
-            <a:off x="548640" y="2011680"/>
-            <a:ext cx="1417320" cy="640080"/>
+            <a:off x="411480" y="1993392"/>
+            <a:ext cx="1234440" cy="411480"/>
+          </a:xfrm>
+          <a:prstGeom prst="rect">
+            <a:avLst/>
+          </a:prstGeom>
+          <a:noFill/>
+          <a:ln/>
+        </p:spPr>
+        <p:txBody>
+          <a:bodyPr wrap="square" rtlCol="0" anchor="ctr"/>
+          <a:lstStyle/>
+          <a:p>
+            <a:pPr indent="0" marL="0">
+              <a:lnSpc>
+                <a:spcPct val="110000"/>
+              </a:lnSpc>
+              <a:buNone/>
+            </a:pPr>
+            <a:r>
+              <a:rPr lang="en-US" sz="1200" b="1" dirty="0">
+                <a:solidFill>
+                  <a:srgbClr val="1A2238"/>
+                </a:solidFill>
+                <a:latin typeface="Microsoft YaHei" pitchFamily="34" charset="0"/>
+                <a:ea typeface="Microsoft YaHei" pitchFamily="34" charset="-122"/>
+                <a:cs typeface="Microsoft YaHei" pitchFamily="34" charset="-120"/>
+              </a:rPr>
+              <a:t>建立关系</a:t>
+            </a:r>
+            <a:endParaRPr lang="en-US" sz="1200" dirty="0"/>
+          </a:p>
+        </p:txBody>
+      </p:sp>
+      <p:sp>
+        <p:nvSpPr>
+          <p:cNvPr id="8" name="Text 6"/>
+          <p:cNvSpPr/>
+          <p:nvPr/>
+        </p:nvSpPr>
+        <p:spPr>
+          <a:xfrm>
+            <a:off x="411480" y="2423160"/>
+            <a:ext cx="1234440" cy="228600"/>
+          </a:xfrm>
+          <a:prstGeom prst="rect">
+            <a:avLst/>
+          </a:prstGeom>
+          <a:noFill/>
+          <a:ln/>
+        </p:spPr>
+        <p:txBody>
+          <a:bodyPr wrap="square" rtlCol="0" anchor="ctr"/>
+          <a:lstStyle/>
+          <a:p>
+            <a:pPr indent="0" marL="0">
+              <a:buNone/>
+            </a:pPr>
+            <a:r>
+              <a:rPr lang="en-US" sz="900" dirty="0">
+                <a:solidFill>
+                  <a:srgbClr val="E2725B"/>
+                </a:solidFill>
+                <a:latin typeface="Microsoft YaHei" pitchFamily="34" charset="0"/>
+                <a:ea typeface="Microsoft YaHei" pitchFamily="34" charset="-122"/>
+                <a:cs typeface="Microsoft YaHei" pitchFamily="34" charset="-120"/>
+              </a:rPr>
+              <a:t>1-3 次</a:t>
+            </a:r>
+            <a:endParaRPr lang="en-US" sz="900" dirty="0"/>
+          </a:p>
+        </p:txBody>
+      </p:sp>
+      <p:sp>
+        <p:nvSpPr>
+          <p:cNvPr id="9" name="Text 7"/>
+          <p:cNvSpPr/>
+          <p:nvPr/>
+        </p:nvSpPr>
+        <p:spPr>
+          <a:xfrm>
+            <a:off x="411480" y="2670048"/>
+            <a:ext cx="1234440" cy="274320"/>
+          </a:xfrm>
+          <a:prstGeom prst="rect">
+            <a:avLst/>
+          </a:prstGeom>
+          <a:noFill/>
+          <a:ln/>
+        </p:spPr>
+        <p:txBody>
+          <a:bodyPr wrap="square" rtlCol="0" anchor="ctr"/>
+          <a:lstStyle/>
+          <a:p>
+            <a:pPr indent="0" marL="0">
+              <a:buNone/>
+            </a:pPr>
+            <a:r>
+              <a:rPr lang="en-US" sz="1000" b="1" dirty="0">
+                <a:solidFill>
+                  <a:srgbClr val="1A2238"/>
+                </a:solidFill>
+                <a:latin typeface="Microsoft YaHei" pitchFamily="34" charset="0"/>
+                <a:ea typeface="Microsoft YaHei" pitchFamily="34" charset="-122"/>
+                <a:cs typeface="Microsoft YaHei" pitchFamily="34" charset="-120"/>
+              </a:rPr>
+              <a:t>依恋为主</a:t>
+            </a:r>
+            <a:endParaRPr lang="en-US" sz="1000" dirty="0"/>
+          </a:p>
+        </p:txBody>
+      </p:sp>
+      <p:sp>
+        <p:nvSpPr>
+          <p:cNvPr id="10" name="Text 8"/>
+          <p:cNvSpPr/>
+          <p:nvPr/>
+        </p:nvSpPr>
+        <p:spPr>
+          <a:xfrm>
+            <a:off x="411480" y="2971800"/>
+            <a:ext cx="1234440" cy="1371600"/>
           </a:xfrm>
           <a:prstGeom prst="rect">
             <a:avLst/>
@@ -11368,88 +11733,7 @@
               <a:buNone/>
             </a:pPr>
             <a:r>
-              <a:rPr lang="en-US" sz="1200" b="1" dirty="0">
-                <a:solidFill>
-                  <a:srgbClr val="1A2238"/>
-                </a:solidFill>
-                <a:latin typeface="Microsoft YaHei" pitchFamily="34" charset="0"/>
-                <a:ea typeface="Microsoft YaHei" pitchFamily="34" charset="-122"/>
-                <a:cs typeface="Microsoft YaHei" pitchFamily="34" charset="-120"/>
-              </a:rPr>
-              <a:t>建立关系与评估</a:t>
-            </a:r>
-            <a:endParaRPr lang="en-US" sz="1200" dirty="0"/>
-          </a:p>
-        </p:txBody>
-      </p:sp>
-      <p:sp>
-        <p:nvSpPr>
-          <p:cNvPr id="8" name="Text 6"/>
-          <p:cNvSpPr/>
-          <p:nvPr/>
-        </p:nvSpPr>
-        <p:spPr>
-          <a:xfrm>
-            <a:off x="548640" y="2697480"/>
-            <a:ext cx="1417320" cy="274320"/>
-          </a:xfrm>
-          <a:prstGeom prst="rect">
-            <a:avLst/>
-          </a:prstGeom>
-          <a:noFill/>
-          <a:ln/>
-        </p:spPr>
-        <p:txBody>
-          <a:bodyPr wrap="square" rtlCol="0" anchor="ctr"/>
-          <a:lstStyle/>
-          <a:p>
-            <a:pPr indent="0" marL="0">
-              <a:buNone/>
-            </a:pPr>
-            <a:r>
-              <a:rPr lang="en-US" sz="1000" dirty="0">
-                <a:solidFill>
-                  <a:srgbClr val="E2725B"/>
-                </a:solidFill>
-                <a:latin typeface="Microsoft YaHei" pitchFamily="34" charset="0"/>
-                <a:ea typeface="Microsoft YaHei" pitchFamily="34" charset="-122"/>
-                <a:cs typeface="Microsoft YaHei" pitchFamily="34" charset="-120"/>
-              </a:rPr>
-              <a:t>1-3 次</a:t>
-            </a:r>
-            <a:endParaRPr lang="en-US" sz="1000" dirty="0"/>
-          </a:p>
-        </p:txBody>
-      </p:sp>
-      <p:sp>
-        <p:nvSpPr>
-          <p:cNvPr id="9" name="Text 7"/>
-          <p:cNvSpPr/>
-          <p:nvPr/>
-        </p:nvSpPr>
-        <p:spPr>
-          <a:xfrm>
-            <a:off x="548640" y="3017520"/>
-            <a:ext cx="1417320" cy="1188720"/>
-          </a:xfrm>
-          <a:prstGeom prst="rect">
-            <a:avLst/>
-          </a:prstGeom>
-          <a:noFill/>
-          <a:ln/>
-        </p:spPr>
-        <p:txBody>
-          <a:bodyPr wrap="square" rtlCol="0" anchor="ctr"/>
-          <a:lstStyle/>
-          <a:p>
-            <a:pPr indent="0" marL="0">
-              <a:lnSpc>
-                <a:spcPct val="130000"/>
-              </a:lnSpc>
-              <a:buNone/>
-            </a:pPr>
-            <a:r>
-              <a:rPr lang="en-US" sz="900" dirty="0">
+              <a:rPr lang="en-US" sz="800" dirty="0">
                 <a:solidFill>
                   <a:srgbClr val="4A5568"/>
                 </a:solidFill>
@@ -11457,31 +11741,11 @@
                 <a:ea typeface="Microsoft YaHei" pitchFamily="34" charset="-122"/>
                 <a:cs typeface="Microsoft YaHei" pitchFamily="34" charset="-120"/>
               </a:rPr>
-              <a:t>收集双轴信息, 建立安全基地, 协商咨询目标</a:t>
-            </a:r>
-            <a:endParaRPr lang="en-US" sz="900" dirty="0"/>
-          </a:p>
-        </p:txBody>
-      </p:sp>
-      <p:sp>
-        <p:nvSpPr>
-          <p:cNvPr id="10" name="Shape 8"/>
-          <p:cNvSpPr/>
-          <p:nvPr/>
-        </p:nvSpPr>
-        <p:spPr>
-          <a:xfrm rot="5400000">
-            <a:off x="2084832" y="2788920"/>
-            <a:ext cx="91440" cy="182880"/>
-          </a:xfrm>
-          <a:prstGeom prst="rtTriangle">
-            <a:avLst/>
-          </a:prstGeom>
-          <a:solidFill>
-            <a:srgbClr val="E2725B"/>
-          </a:solidFill>
-          <a:ln/>
-        </p:spPr>
+              <a:t>建立安全基地, 让来访者开始"重复"给你看</a:t>
+            </a:r>
+            <a:endParaRPr lang="en-US" sz="800" dirty="0"/>
+          </a:p>
+        </p:txBody>
       </p:sp>
       <p:sp>
         <p:nvSpPr>
@@ -11491,8 +11755,8 @@
         </p:nvSpPr>
         <p:spPr>
           <a:xfrm>
-            <a:off x="2148840" y="1554480"/>
-            <a:ext cx="1600200" cy="2743200"/>
+            <a:off x="1783080" y="1554480"/>
+            <a:ext cx="1325880" cy="2926080"/>
           </a:xfrm>
           <a:prstGeom prst="rect">
             <a:avLst/>
@@ -11516,8 +11780,8 @@
         </p:nvSpPr>
         <p:spPr>
           <a:xfrm>
-            <a:off x="2148840" y="1554480"/>
-            <a:ext cx="1600200" cy="365760"/>
+            <a:off x="1783080" y="1554480"/>
+            <a:ext cx="1325880" cy="365760"/>
           </a:xfrm>
           <a:prstGeom prst="rect">
             <a:avLst/>
@@ -11536,8 +11800,8 @@
         </p:nvSpPr>
         <p:spPr>
           <a:xfrm>
-            <a:off x="2148840" y="1600200"/>
-            <a:ext cx="1600200" cy="274320"/>
+            <a:off x="1783080" y="1600200"/>
+            <a:ext cx="1325880" cy="274320"/>
           </a:xfrm>
           <a:prstGeom prst="rect">
             <a:avLst/>
@@ -11575,8 +11839,128 @@
         </p:nvSpPr>
         <p:spPr>
           <a:xfrm>
-            <a:off x="2240280" y="2011680"/>
-            <a:ext cx="1417320" cy="640080"/>
+            <a:off x="1828800" y="1993392"/>
+            <a:ext cx="1234440" cy="411480"/>
+          </a:xfrm>
+          <a:prstGeom prst="rect">
+            <a:avLst/>
+          </a:prstGeom>
+          <a:noFill/>
+          <a:ln/>
+        </p:spPr>
+        <p:txBody>
+          <a:bodyPr wrap="square" rtlCol="0" anchor="ctr"/>
+          <a:lstStyle/>
+          <a:p>
+            <a:pPr indent="0" marL="0">
+              <a:lnSpc>
+                <a:spcPct val="110000"/>
+              </a:lnSpc>
+              <a:buNone/>
+            </a:pPr>
+            <a:r>
+              <a:rPr lang="en-US" sz="1200" b="1" dirty="0">
+                <a:solidFill>
+                  <a:srgbClr val="1A2238"/>
+                </a:solidFill>
+                <a:latin typeface="Microsoft YaHei" pitchFamily="34" charset="0"/>
+                <a:ea typeface="Microsoft YaHei" pitchFamily="34" charset="-122"/>
+                <a:cs typeface="Microsoft YaHei" pitchFamily="34" charset="-120"/>
+              </a:rPr>
+              <a:t>看见模式</a:t>
+            </a:r>
+            <a:endParaRPr lang="en-US" sz="1200" dirty="0"/>
+          </a:p>
+        </p:txBody>
+      </p:sp>
+      <p:sp>
+        <p:nvSpPr>
+          <p:cNvPr id="15" name="Text 13"/>
+          <p:cNvSpPr/>
+          <p:nvPr/>
+        </p:nvSpPr>
+        <p:spPr>
+          <a:xfrm>
+            <a:off x="1828800" y="2423160"/>
+            <a:ext cx="1234440" cy="228600"/>
+          </a:xfrm>
+          <a:prstGeom prst="rect">
+            <a:avLst/>
+          </a:prstGeom>
+          <a:noFill/>
+          <a:ln/>
+        </p:spPr>
+        <p:txBody>
+          <a:bodyPr wrap="square" rtlCol="0" anchor="ctr"/>
+          <a:lstStyle/>
+          <a:p>
+            <a:pPr indent="0" marL="0">
+              <a:buNone/>
+            </a:pPr>
+            <a:r>
+              <a:rPr lang="en-US" sz="900" dirty="0">
+                <a:solidFill>
+                  <a:srgbClr val="E2725B"/>
+                </a:solidFill>
+                <a:latin typeface="Microsoft YaHei" pitchFamily="34" charset="0"/>
+                <a:ea typeface="Microsoft YaHei" pitchFamily="34" charset="-122"/>
+                <a:cs typeface="Microsoft YaHei" pitchFamily="34" charset="-120"/>
+              </a:rPr>
+              <a:t>4-8 次</a:t>
+            </a:r>
+            <a:endParaRPr lang="en-US" sz="900" dirty="0"/>
+          </a:p>
+        </p:txBody>
+      </p:sp>
+      <p:sp>
+        <p:nvSpPr>
+          <p:cNvPr id="16" name="Text 14"/>
+          <p:cNvSpPr/>
+          <p:nvPr/>
+        </p:nvSpPr>
+        <p:spPr>
+          <a:xfrm>
+            <a:off x="1828800" y="2670048"/>
+            <a:ext cx="1234440" cy="274320"/>
+          </a:xfrm>
+          <a:prstGeom prst="rect">
+            <a:avLst/>
+          </a:prstGeom>
+          <a:noFill/>
+          <a:ln/>
+        </p:spPr>
+        <p:txBody>
+          <a:bodyPr wrap="square" rtlCol="0" anchor="ctr"/>
+          <a:lstStyle/>
+          <a:p>
+            <a:pPr indent="0" marL="0">
+              <a:buNone/>
+            </a:pPr>
+            <a:r>
+              <a:rPr lang="en-US" sz="1000" b="1" dirty="0">
+                <a:solidFill>
+                  <a:srgbClr val="1A2238"/>
+                </a:solidFill>
+                <a:latin typeface="Microsoft YaHei" pitchFamily="34" charset="0"/>
+                <a:ea typeface="Microsoft YaHei" pitchFamily="34" charset="-122"/>
+                <a:cs typeface="Microsoft YaHei" pitchFamily="34" charset="-120"/>
+              </a:rPr>
+              <a:t>依恋+九型</a:t>
+            </a:r>
+            <a:endParaRPr lang="en-US" sz="1000" dirty="0"/>
+          </a:p>
+        </p:txBody>
+      </p:sp>
+      <p:sp>
+        <p:nvSpPr>
+          <p:cNvPr id="17" name="Text 15"/>
+          <p:cNvSpPr/>
+          <p:nvPr/>
+        </p:nvSpPr>
+        <p:spPr>
+          <a:xfrm>
+            <a:off x="1828800" y="2971800"/>
+            <a:ext cx="1234440" cy="1371600"/>
           </a:xfrm>
           <a:prstGeom prst="rect">
             <a:avLst/>
@@ -11595,88 +11979,7 @@
               <a:buNone/>
             </a:pPr>
             <a:r>
-              <a:rPr lang="en-US" sz="1200" b="1" dirty="0">
-                <a:solidFill>
-                  <a:srgbClr val="1A2238"/>
-                </a:solidFill>
-                <a:latin typeface="Microsoft YaHei" pitchFamily="34" charset="0"/>
-                <a:ea typeface="Microsoft YaHei" pitchFamily="34" charset="-122"/>
-                <a:cs typeface="Microsoft YaHei" pitchFamily="34" charset="-120"/>
-              </a:rPr>
-              <a:t>看见模式与触发</a:t>
-            </a:r>
-            <a:endParaRPr lang="en-US" sz="1200" dirty="0"/>
-          </a:p>
-        </p:txBody>
-      </p:sp>
-      <p:sp>
-        <p:nvSpPr>
-          <p:cNvPr id="15" name="Text 13"/>
-          <p:cNvSpPr/>
-          <p:nvPr/>
-        </p:nvSpPr>
-        <p:spPr>
-          <a:xfrm>
-            <a:off x="2240280" y="2697480"/>
-            <a:ext cx="1417320" cy="274320"/>
-          </a:xfrm>
-          <a:prstGeom prst="rect">
-            <a:avLst/>
-          </a:prstGeom>
-          <a:noFill/>
-          <a:ln/>
-        </p:spPr>
-        <p:txBody>
-          <a:bodyPr wrap="square" rtlCol="0" anchor="ctr"/>
-          <a:lstStyle/>
-          <a:p>
-            <a:pPr indent="0" marL="0">
-              <a:buNone/>
-            </a:pPr>
-            <a:r>
-              <a:rPr lang="en-US" sz="1000" dirty="0">
-                <a:solidFill>
-                  <a:srgbClr val="E2725B"/>
-                </a:solidFill>
-                <a:latin typeface="Microsoft YaHei" pitchFamily="34" charset="0"/>
-                <a:ea typeface="Microsoft YaHei" pitchFamily="34" charset="-122"/>
-                <a:cs typeface="Microsoft YaHei" pitchFamily="34" charset="-120"/>
-              </a:rPr>
-              <a:t>4-8 次</a:t>
-            </a:r>
-            <a:endParaRPr lang="en-US" sz="1000" dirty="0"/>
-          </a:p>
-        </p:txBody>
-      </p:sp>
-      <p:sp>
-        <p:nvSpPr>
-          <p:cNvPr id="16" name="Text 14"/>
-          <p:cNvSpPr/>
-          <p:nvPr/>
-        </p:nvSpPr>
-        <p:spPr>
-          <a:xfrm>
-            <a:off x="2240280" y="3017520"/>
-            <a:ext cx="1417320" cy="1188720"/>
-          </a:xfrm>
-          <a:prstGeom prst="rect">
-            <a:avLst/>
-          </a:prstGeom>
-          <a:noFill/>
-          <a:ln/>
-        </p:spPr>
-        <p:txBody>
-          <a:bodyPr wrap="square" rtlCol="0" anchor="ctr"/>
-          <a:lstStyle/>
-          <a:p>
-            <a:pPr indent="0" marL="0">
-              <a:lnSpc>
-                <a:spcPct val="130000"/>
-              </a:lnSpc>
-              <a:buNone/>
-            </a:pPr>
-            <a:r>
-              <a:rPr lang="en-US" sz="900" dirty="0">
+              <a:rPr lang="en-US" sz="800" dirty="0">
                 <a:solidFill>
                   <a:srgbClr val="4A5568"/>
                 </a:solidFill>
@@ -11684,31 +11987,11 @@
                 <a:ea typeface="Microsoft YaHei" pitchFamily="34" charset="-122"/>
                 <a:cs typeface="Microsoft YaHei" pitchFamily="34" charset="-120"/>
               </a:rPr>
-              <a:t>命名激活模式, 建立预警信号, 触碰早期剧本</a:t>
-            </a:r>
-            <a:endParaRPr lang="en-US" sz="900" dirty="0"/>
-          </a:p>
-        </p:txBody>
-      </p:sp>
-      <p:sp>
-        <p:nvSpPr>
-          <p:cNvPr id="17" name="Shape 15"/>
-          <p:cNvSpPr/>
-          <p:nvPr/>
-        </p:nvSpPr>
-        <p:spPr>
-          <a:xfrm rot="5400000">
-            <a:off x="3776472" y="2788920"/>
-            <a:ext cx="91440" cy="182880"/>
-          </a:xfrm>
-          <a:prstGeom prst="rtTriangle">
-            <a:avLst/>
-          </a:prstGeom>
-          <a:solidFill>
-            <a:srgbClr val="E2725B"/>
-          </a:solidFill>
-          <a:ln/>
-        </p:spPr>
+              <a:t>识别激活模式 + 防御位</a:t>
+            </a:r>
+            <a:endParaRPr lang="en-US" sz="800" dirty="0"/>
+          </a:p>
+        </p:txBody>
       </p:sp>
       <p:sp>
         <p:nvSpPr>
@@ -11718,8 +12001,8 @@
         </p:nvSpPr>
         <p:spPr>
           <a:xfrm>
-            <a:off x="3840480" y="1554480"/>
-            <a:ext cx="1600200" cy="2743200"/>
+            <a:off x="3200400" y="1554480"/>
+            <a:ext cx="1325880" cy="2926080"/>
           </a:xfrm>
           <a:prstGeom prst="rect">
             <a:avLst/>
@@ -11743,8 +12026,8 @@
         </p:nvSpPr>
         <p:spPr>
           <a:xfrm>
-            <a:off x="3840480" y="1554480"/>
-            <a:ext cx="1600200" cy="365760"/>
+            <a:off x="3200400" y="1554480"/>
+            <a:ext cx="1325880" cy="365760"/>
           </a:xfrm>
           <a:prstGeom prst="rect">
             <a:avLst/>
@@ -11763,8 +12046,8 @@
         </p:nvSpPr>
         <p:spPr>
           <a:xfrm>
-            <a:off x="3840480" y="1600200"/>
-            <a:ext cx="1600200" cy="274320"/>
+            <a:off x="3200400" y="1600200"/>
+            <a:ext cx="1325880" cy="274320"/>
           </a:xfrm>
           <a:prstGeom prst="rect">
             <a:avLst/>
@@ -11802,8 +12085,128 @@
         </p:nvSpPr>
         <p:spPr>
           <a:xfrm>
-            <a:off x="3931920" y="2011680"/>
-            <a:ext cx="1417320" cy="640080"/>
+            <a:off x="3246120" y="1993392"/>
+            <a:ext cx="1234440" cy="411480"/>
+          </a:xfrm>
+          <a:prstGeom prst="rect">
+            <a:avLst/>
+          </a:prstGeom>
+          <a:noFill/>
+          <a:ln/>
+        </p:spPr>
+        <p:txBody>
+          <a:bodyPr wrap="square" rtlCol="0" anchor="ctr"/>
+          <a:lstStyle/>
+          <a:p>
+            <a:pPr indent="0" marL="0">
+              <a:lnSpc>
+                <a:spcPct val="110000"/>
+              </a:lnSpc>
+              <a:buNone/>
+            </a:pPr>
+            <a:r>
+              <a:rPr lang="en-US" sz="1200" b="1" dirty="0">
+                <a:solidFill>
+                  <a:srgbClr val="1A2238"/>
+                </a:solidFill>
+                <a:latin typeface="Microsoft YaHei" pitchFamily="34" charset="0"/>
+                <a:ea typeface="Microsoft YaHei" pitchFamily="34" charset="-122"/>
+                <a:cs typeface="Microsoft YaHei" pitchFamily="34" charset="-120"/>
+              </a:rPr>
+              <a:t>看见动力</a:t>
+            </a:r>
+            <a:endParaRPr lang="en-US" sz="1200" dirty="0"/>
+          </a:p>
+        </p:txBody>
+      </p:sp>
+      <p:sp>
+        <p:nvSpPr>
+          <p:cNvPr id="22" name="Text 20"/>
+          <p:cNvSpPr/>
+          <p:nvPr/>
+        </p:nvSpPr>
+        <p:spPr>
+          <a:xfrm>
+            <a:off x="3246120" y="2423160"/>
+            <a:ext cx="1234440" cy="228600"/>
+          </a:xfrm>
+          <a:prstGeom prst="rect">
+            <a:avLst/>
+          </a:prstGeom>
+          <a:noFill/>
+          <a:ln/>
+        </p:spPr>
+        <p:txBody>
+          <a:bodyPr wrap="square" rtlCol="0" anchor="ctr"/>
+          <a:lstStyle/>
+          <a:p>
+            <a:pPr indent="0" marL="0">
+              <a:buNone/>
+            </a:pPr>
+            <a:r>
+              <a:rPr lang="en-US" sz="900" dirty="0">
+                <a:solidFill>
+                  <a:srgbClr val="E2725B"/>
+                </a:solidFill>
+                <a:latin typeface="Microsoft YaHei" pitchFamily="34" charset="0"/>
+                <a:ea typeface="Microsoft YaHei" pitchFamily="34" charset="-122"/>
+                <a:cs typeface="Microsoft YaHei" pitchFamily="34" charset="-120"/>
+              </a:rPr>
+              <a:t>9-15 次</a:t>
+            </a:r>
+            <a:endParaRPr lang="en-US" sz="900" dirty="0"/>
+          </a:p>
+        </p:txBody>
+      </p:sp>
+      <p:sp>
+        <p:nvSpPr>
+          <p:cNvPr id="23" name="Text 21"/>
+          <p:cNvSpPr/>
+          <p:nvPr/>
+        </p:nvSpPr>
+        <p:spPr>
+          <a:xfrm>
+            <a:off x="3246120" y="2670048"/>
+            <a:ext cx="1234440" cy="274320"/>
+          </a:xfrm>
+          <a:prstGeom prst="rect">
+            <a:avLst/>
+          </a:prstGeom>
+          <a:noFill/>
+          <a:ln/>
+        </p:spPr>
+        <p:txBody>
+          <a:bodyPr wrap="square" rtlCol="0" anchor="ctr"/>
+          <a:lstStyle/>
+          <a:p>
+            <a:pPr indent="0" marL="0">
+              <a:buNone/>
+            </a:pPr>
+            <a:r>
+              <a:rPr lang="en-US" sz="1000" b="1" dirty="0">
+                <a:solidFill>
+                  <a:srgbClr val="1A2238"/>
+                </a:solidFill>
+                <a:latin typeface="Microsoft YaHei" pitchFamily="34" charset="0"/>
+                <a:ea typeface="Microsoft YaHei" pitchFamily="34" charset="-122"/>
+                <a:cs typeface="Microsoft YaHei" pitchFamily="34" charset="-120"/>
+              </a:rPr>
+              <a:t>九型+客体</a:t>
+            </a:r>
+            <a:endParaRPr lang="en-US" sz="1000" dirty="0"/>
+          </a:p>
+        </p:txBody>
+      </p:sp>
+      <p:sp>
+        <p:nvSpPr>
+          <p:cNvPr id="24" name="Text 22"/>
+          <p:cNvSpPr/>
+          <p:nvPr/>
+        </p:nvSpPr>
+        <p:spPr>
+          <a:xfrm>
+            <a:off x="3246120" y="2971800"/>
+            <a:ext cx="1234440" cy="1371600"/>
           </a:xfrm>
           <a:prstGeom prst="rect">
             <a:avLst/>
@@ -11822,88 +12225,7 @@
               <a:buNone/>
             </a:pPr>
             <a:r>
-              <a:rPr lang="en-US" sz="1200" b="1" dirty="0">
-                <a:solidFill>
-                  <a:srgbClr val="1A2238"/>
-                </a:solidFill>
-                <a:latin typeface="Microsoft YaHei" pitchFamily="34" charset="0"/>
-                <a:ea typeface="Microsoft YaHei" pitchFamily="34" charset="-122"/>
-                <a:cs typeface="Microsoft YaHei" pitchFamily="34" charset="-120"/>
-              </a:rPr>
-              <a:t>哀悼与重建</a:t>
-            </a:r>
-            <a:endParaRPr lang="en-US" sz="1200" dirty="0"/>
-          </a:p>
-        </p:txBody>
-      </p:sp>
-      <p:sp>
-        <p:nvSpPr>
-          <p:cNvPr id="22" name="Text 20"/>
-          <p:cNvSpPr/>
-          <p:nvPr/>
-        </p:nvSpPr>
-        <p:spPr>
-          <a:xfrm>
-            <a:off x="3931920" y="2697480"/>
-            <a:ext cx="1417320" cy="274320"/>
-          </a:xfrm>
-          <a:prstGeom prst="rect">
-            <a:avLst/>
-          </a:prstGeom>
-          <a:noFill/>
-          <a:ln/>
-        </p:spPr>
-        <p:txBody>
-          <a:bodyPr wrap="square" rtlCol="0" anchor="ctr"/>
-          <a:lstStyle/>
-          <a:p>
-            <a:pPr indent="0" marL="0">
-              <a:buNone/>
-            </a:pPr>
-            <a:r>
-              <a:rPr lang="en-US" sz="1000" dirty="0">
-                <a:solidFill>
-                  <a:srgbClr val="E2725B"/>
-                </a:solidFill>
-                <a:latin typeface="Microsoft YaHei" pitchFamily="34" charset="0"/>
-                <a:ea typeface="Microsoft YaHei" pitchFamily="34" charset="-122"/>
-                <a:cs typeface="Microsoft YaHei" pitchFamily="34" charset="-120"/>
-              </a:rPr>
-              <a:t>9-15 次</a:t>
-            </a:r>
-            <a:endParaRPr lang="en-US" sz="1000" dirty="0"/>
-          </a:p>
-        </p:txBody>
-      </p:sp>
-      <p:sp>
-        <p:nvSpPr>
-          <p:cNvPr id="23" name="Text 21"/>
-          <p:cNvSpPr/>
-          <p:nvPr/>
-        </p:nvSpPr>
-        <p:spPr>
-          <a:xfrm>
-            <a:off x="3931920" y="3017520"/>
-            <a:ext cx="1417320" cy="1188720"/>
-          </a:xfrm>
-          <a:prstGeom prst="rect">
-            <a:avLst/>
-          </a:prstGeom>
-          <a:noFill/>
-          <a:ln/>
-        </p:spPr>
-        <p:txBody>
-          <a:bodyPr wrap="square" rtlCol="0" anchor="ctr"/>
-          <a:lstStyle/>
-          <a:p>
-            <a:pPr indent="0" marL="0">
-              <a:lnSpc>
-                <a:spcPct val="130000"/>
-              </a:lnSpc>
-              <a:buNone/>
-            </a:pPr>
-            <a:r>
-              <a:rPr lang="en-US" sz="900" dirty="0">
+              <a:rPr lang="en-US" sz="800" dirty="0">
                 <a:solidFill>
                   <a:srgbClr val="4A5568"/>
                 </a:solidFill>
@@ -11911,31 +12233,11 @@
                 <a:ea typeface="Microsoft YaHei" pitchFamily="34" charset="-122"/>
                 <a:cs typeface="Microsoft YaHei" pitchFamily="34" charset="-120"/>
               </a:rPr>
-              <a:t>哀悼理想化依恋对象, 看见核心恐惧根源</a:t>
-            </a:r>
-            <a:endParaRPr lang="en-US" sz="900" dirty="0"/>
-          </a:p>
-        </p:txBody>
-      </p:sp>
-      <p:sp>
-        <p:nvSpPr>
-          <p:cNvPr id="24" name="Shape 22"/>
-          <p:cNvSpPr/>
-          <p:nvPr/>
-        </p:nvSpPr>
-        <p:spPr>
-          <a:xfrm rot="5400000">
-            <a:off x="5468112" y="2788920"/>
-            <a:ext cx="91440" cy="182880"/>
-          </a:xfrm>
-          <a:prstGeom prst="rtTriangle">
-            <a:avLst/>
-          </a:prstGeom>
-          <a:solidFill>
-            <a:srgbClr val="E2725B"/>
-          </a:solidFill>
-          <a:ln/>
-        </p:spPr>
+              <a:t>核心恐惧暴露 + 反移情浮现</a:t>
+            </a:r>
+            <a:endParaRPr lang="en-US" sz="800" dirty="0"/>
+          </a:p>
+        </p:txBody>
       </p:sp>
       <p:sp>
         <p:nvSpPr>
@@ -11945,8 +12247,8 @@
         </p:nvSpPr>
         <p:spPr>
           <a:xfrm>
-            <a:off x="5532120" y="1554480"/>
-            <a:ext cx="1600200" cy="2743200"/>
+            <a:off x="4617720" y="1554480"/>
+            <a:ext cx="1325880" cy="2926080"/>
           </a:xfrm>
           <a:prstGeom prst="rect">
             <a:avLst/>
@@ -11970,8 +12272,8 @@
         </p:nvSpPr>
         <p:spPr>
           <a:xfrm>
-            <a:off x="5532120" y="1554480"/>
-            <a:ext cx="1600200" cy="365760"/>
+            <a:off x="4617720" y="1554480"/>
+            <a:ext cx="1325880" cy="365760"/>
           </a:xfrm>
           <a:prstGeom prst="rect">
             <a:avLst/>
@@ -11990,8 +12292,8 @@
         </p:nvSpPr>
         <p:spPr>
           <a:xfrm>
-            <a:off x="5532120" y="1600200"/>
-            <a:ext cx="1600200" cy="274320"/>
+            <a:off x="4617720" y="1600200"/>
+            <a:ext cx="1325880" cy="274320"/>
           </a:xfrm>
           <a:prstGeom prst="rect">
             <a:avLst/>
@@ -12029,8 +12331,128 @@
         </p:nvSpPr>
         <p:spPr>
           <a:xfrm>
-            <a:off x="5623560" y="2011680"/>
-            <a:ext cx="1417320" cy="640080"/>
+            <a:off x="4663440" y="1993392"/>
+            <a:ext cx="1234440" cy="411480"/>
+          </a:xfrm>
+          <a:prstGeom prst="rect">
+            <a:avLst/>
+          </a:prstGeom>
+          <a:noFill/>
+          <a:ln/>
+        </p:spPr>
+        <p:txBody>
+          <a:bodyPr wrap="square" rtlCol="0" anchor="ctr"/>
+          <a:lstStyle/>
+          <a:p>
+            <a:pPr indent="0" marL="0">
+              <a:lnSpc>
+                <a:spcPct val="110000"/>
+              </a:lnSpc>
+              <a:buNone/>
+            </a:pPr>
+            <a:r>
+              <a:rPr lang="en-US" sz="1200" b="1" dirty="0">
+                <a:solidFill>
+                  <a:srgbClr val="1A2238"/>
+                </a:solidFill>
+                <a:latin typeface="Microsoft YaHei" pitchFamily="34" charset="0"/>
+                <a:ea typeface="Microsoft YaHei" pitchFamily="34" charset="-122"/>
+                <a:cs typeface="Microsoft YaHei" pitchFamily="34" charset="-120"/>
+              </a:rPr>
+              <a:t>修补结构</a:t>
+            </a:r>
+            <a:endParaRPr lang="en-US" sz="1200" dirty="0"/>
+          </a:p>
+        </p:txBody>
+      </p:sp>
+      <p:sp>
+        <p:nvSpPr>
+          <p:cNvPr id="29" name="Text 27"/>
+          <p:cNvSpPr/>
+          <p:nvPr/>
+        </p:nvSpPr>
+        <p:spPr>
+          <a:xfrm>
+            <a:off x="4663440" y="2423160"/>
+            <a:ext cx="1234440" cy="228600"/>
+          </a:xfrm>
+          <a:prstGeom prst="rect">
+            <a:avLst/>
+          </a:prstGeom>
+          <a:noFill/>
+          <a:ln/>
+        </p:spPr>
+        <p:txBody>
+          <a:bodyPr wrap="square" rtlCol="0" anchor="ctr"/>
+          <a:lstStyle/>
+          <a:p>
+            <a:pPr indent="0" marL="0">
+              <a:buNone/>
+            </a:pPr>
+            <a:r>
+              <a:rPr lang="en-US" sz="900" dirty="0">
+                <a:solidFill>
+                  <a:srgbClr val="E2725B"/>
+                </a:solidFill>
+                <a:latin typeface="Microsoft YaHei" pitchFamily="34" charset="0"/>
+                <a:ea typeface="Microsoft YaHei" pitchFamily="34" charset="-122"/>
+                <a:cs typeface="Microsoft YaHei" pitchFamily="34" charset="-120"/>
+              </a:rPr>
+              <a:t>16-25 次</a:t>
+            </a:r>
+            <a:endParaRPr lang="en-US" sz="900" dirty="0"/>
+          </a:p>
+        </p:txBody>
+      </p:sp>
+      <p:sp>
+        <p:nvSpPr>
+          <p:cNvPr id="30" name="Text 28"/>
+          <p:cNvSpPr/>
+          <p:nvPr/>
+        </p:nvSpPr>
+        <p:spPr>
+          <a:xfrm>
+            <a:off x="4663440" y="2670048"/>
+            <a:ext cx="1234440" cy="274320"/>
+          </a:xfrm>
+          <a:prstGeom prst="rect">
+            <a:avLst/>
+          </a:prstGeom>
+          <a:noFill/>
+          <a:ln/>
+        </p:spPr>
+        <p:txBody>
+          <a:bodyPr wrap="square" rtlCol="0" anchor="ctr"/>
+          <a:lstStyle/>
+          <a:p>
+            <a:pPr indent="0" marL="0">
+              <a:buNone/>
+            </a:pPr>
+            <a:r>
+              <a:rPr lang="en-US" sz="1000" b="1" dirty="0">
+                <a:solidFill>
+                  <a:srgbClr val="1A2238"/>
+                </a:solidFill>
+                <a:latin typeface="Microsoft YaHei" pitchFamily="34" charset="0"/>
+                <a:ea typeface="Microsoft YaHei" pitchFamily="34" charset="-122"/>
+                <a:cs typeface="Microsoft YaHei" pitchFamily="34" charset="-120"/>
+              </a:rPr>
+              <a:t>客体为主</a:t>
+            </a:r>
+            <a:endParaRPr lang="en-US" sz="1000" dirty="0"/>
+          </a:p>
+        </p:txBody>
+      </p:sp>
+      <p:sp>
+        <p:nvSpPr>
+          <p:cNvPr id="31" name="Text 29"/>
+          <p:cNvSpPr/>
+          <p:nvPr/>
+        </p:nvSpPr>
+        <p:spPr>
+          <a:xfrm>
+            <a:off x="4663440" y="2971800"/>
+            <a:ext cx="1234440" cy="1371600"/>
           </a:xfrm>
           <a:prstGeom prst="rect">
             <a:avLst/>
@@ -12049,88 +12471,7 @@
               <a:buNone/>
             </a:pPr>
             <a:r>
-              <a:rPr lang="en-US" sz="1200" b="1" dirty="0">
-                <a:solidFill>
-                  <a:srgbClr val="1A2238"/>
-                </a:solidFill>
-                <a:latin typeface="Microsoft YaHei" pitchFamily="34" charset="0"/>
-                <a:ea typeface="Microsoft YaHei" pitchFamily="34" charset="-122"/>
-                <a:cs typeface="Microsoft YaHei" pitchFamily="34" charset="-120"/>
-              </a:rPr>
-              <a:t>新经验与整合</a:t>
-            </a:r>
-            <a:endParaRPr lang="en-US" sz="1200" dirty="0"/>
-          </a:p>
-        </p:txBody>
-      </p:sp>
-      <p:sp>
-        <p:nvSpPr>
-          <p:cNvPr id="29" name="Text 27"/>
-          <p:cNvSpPr/>
-          <p:nvPr/>
-        </p:nvSpPr>
-        <p:spPr>
-          <a:xfrm>
-            <a:off x="5623560" y="2697480"/>
-            <a:ext cx="1417320" cy="274320"/>
-          </a:xfrm>
-          <a:prstGeom prst="rect">
-            <a:avLst/>
-          </a:prstGeom>
-          <a:noFill/>
-          <a:ln/>
-        </p:spPr>
-        <p:txBody>
-          <a:bodyPr wrap="square" rtlCol="0" anchor="ctr"/>
-          <a:lstStyle/>
-          <a:p>
-            <a:pPr indent="0" marL="0">
-              <a:buNone/>
-            </a:pPr>
-            <a:r>
-              <a:rPr lang="en-US" sz="1000" dirty="0">
-                <a:solidFill>
-                  <a:srgbClr val="E2725B"/>
-                </a:solidFill>
-                <a:latin typeface="Microsoft YaHei" pitchFamily="34" charset="0"/>
-                <a:ea typeface="Microsoft YaHei" pitchFamily="34" charset="-122"/>
-                <a:cs typeface="Microsoft YaHei" pitchFamily="34" charset="-120"/>
-              </a:rPr>
-              <a:t>16-25 次</a:t>
-            </a:r>
-            <a:endParaRPr lang="en-US" sz="1000" dirty="0"/>
-          </a:p>
-        </p:txBody>
-      </p:sp>
-      <p:sp>
-        <p:nvSpPr>
-          <p:cNvPr id="30" name="Text 28"/>
-          <p:cNvSpPr/>
-          <p:nvPr/>
-        </p:nvSpPr>
-        <p:spPr>
-          <a:xfrm>
-            <a:off x="5623560" y="3017520"/>
-            <a:ext cx="1417320" cy="1188720"/>
-          </a:xfrm>
-          <a:prstGeom prst="rect">
-            <a:avLst/>
-          </a:prstGeom>
-          <a:noFill/>
-          <a:ln/>
-        </p:spPr>
-        <p:txBody>
-          <a:bodyPr wrap="square" rtlCol="0" anchor="ctr"/>
-          <a:lstStyle/>
-          <a:p>
-            <a:pPr indent="0" marL="0">
-              <a:lnSpc>
-                <a:spcPct val="130000"/>
-              </a:lnSpc>
-              <a:buNone/>
-            </a:pPr>
-            <a:r>
-              <a:rPr lang="en-US" sz="900" dirty="0">
+              <a:rPr lang="en-US" sz="800" dirty="0">
                 <a:solidFill>
                   <a:srgbClr val="4A5568"/>
                 </a:solidFill>
@@ -12138,31 +12479,11 @@
                 <a:ea typeface="Microsoft YaHei" pitchFamily="34" charset="-122"/>
                 <a:cs typeface="Microsoft YaHei" pitchFamily="34" charset="-120"/>
               </a:rPr>
-              <a:t>矫正性情感经验, 整合依恋修复与九型成长</a:t>
-            </a:r>
-            <a:endParaRPr lang="en-US" sz="900" dirty="0"/>
-          </a:p>
-        </p:txBody>
-      </p:sp>
-      <p:sp>
-        <p:nvSpPr>
-          <p:cNvPr id="31" name="Shape 29"/>
-          <p:cNvSpPr/>
-          <p:nvPr/>
-        </p:nvSpPr>
-        <p:spPr>
-          <a:xfrm rot="5400000">
-            <a:off x="7159752" y="2788920"/>
-            <a:ext cx="91440" cy="182880"/>
-          </a:xfrm>
-          <a:prstGeom prst="rtTriangle">
-            <a:avLst/>
-          </a:prstGeom>
-          <a:solidFill>
-            <a:srgbClr val="E2725B"/>
-          </a:solidFill>
-          <a:ln/>
-        </p:spPr>
+              <a:t>破裂-修复循环, 修补内在图</a:t>
+            </a:r>
+            <a:endParaRPr lang="en-US" sz="800" dirty="0"/>
+          </a:p>
+        </p:txBody>
       </p:sp>
       <p:sp>
         <p:nvSpPr>
@@ -12172,8 +12493,8 @@
         </p:nvSpPr>
         <p:spPr>
           <a:xfrm>
-            <a:off x="7223760" y="1554480"/>
-            <a:ext cx="1600200" cy="2743200"/>
+            <a:off x="6035040" y="1554480"/>
+            <a:ext cx="1325880" cy="2926080"/>
           </a:xfrm>
           <a:prstGeom prst="rect">
             <a:avLst/>
@@ -12197,8 +12518,8 @@
         </p:nvSpPr>
         <p:spPr>
           <a:xfrm>
-            <a:off x="7223760" y="1554480"/>
-            <a:ext cx="1600200" cy="365760"/>
+            <a:off x="6035040" y="1554480"/>
+            <a:ext cx="1325880" cy="365760"/>
           </a:xfrm>
           <a:prstGeom prst="rect">
             <a:avLst/>
@@ -12217,8 +12538,8 @@
         </p:nvSpPr>
         <p:spPr>
           <a:xfrm>
-            <a:off x="7223760" y="1600200"/>
-            <a:ext cx="1600200" cy="274320"/>
+            <a:off x="6035040" y="1600200"/>
+            <a:ext cx="1325880" cy="274320"/>
           </a:xfrm>
           <a:prstGeom prst="rect">
             <a:avLst/>
@@ -12256,8 +12577,128 @@
         </p:nvSpPr>
         <p:spPr>
           <a:xfrm>
-            <a:off x="7315200" y="2011680"/>
-            <a:ext cx="1417320" cy="640080"/>
+            <a:off x="6080760" y="1993392"/>
+            <a:ext cx="1234440" cy="411480"/>
+          </a:xfrm>
+          <a:prstGeom prst="rect">
+            <a:avLst/>
+          </a:prstGeom>
+          <a:noFill/>
+          <a:ln/>
+        </p:spPr>
+        <p:txBody>
+          <a:bodyPr wrap="square" rtlCol="0" anchor="ctr"/>
+          <a:lstStyle/>
+          <a:p>
+            <a:pPr indent="0" marL="0">
+              <a:lnSpc>
+                <a:spcPct val="110000"/>
+              </a:lnSpc>
+              <a:buNone/>
+            </a:pPr>
+            <a:r>
+              <a:rPr lang="en-US" sz="1200" b="1" dirty="0">
+                <a:solidFill>
+                  <a:srgbClr val="1A2238"/>
+                </a:solidFill>
+                <a:latin typeface="Microsoft YaHei" pitchFamily="34" charset="0"/>
+                <a:ea typeface="Microsoft YaHei" pitchFamily="34" charset="-122"/>
+                <a:cs typeface="Microsoft YaHei" pitchFamily="34" charset="-120"/>
+              </a:rPr>
+              <a:t>巩固整合</a:t>
+            </a:r>
+            <a:endParaRPr lang="en-US" sz="1200" dirty="0"/>
+          </a:p>
+        </p:txBody>
+      </p:sp>
+      <p:sp>
+        <p:nvSpPr>
+          <p:cNvPr id="36" name="Text 34"/>
+          <p:cNvSpPr/>
+          <p:nvPr/>
+        </p:nvSpPr>
+        <p:spPr>
+          <a:xfrm>
+            <a:off x="6080760" y="2423160"/>
+            <a:ext cx="1234440" cy="228600"/>
+          </a:xfrm>
+          <a:prstGeom prst="rect">
+            <a:avLst/>
+          </a:prstGeom>
+          <a:noFill/>
+          <a:ln/>
+        </p:spPr>
+        <p:txBody>
+          <a:bodyPr wrap="square" rtlCol="0" anchor="ctr"/>
+          <a:lstStyle/>
+          <a:p>
+            <a:pPr indent="0" marL="0">
+              <a:buNone/>
+            </a:pPr>
+            <a:r>
+              <a:rPr lang="en-US" sz="900" dirty="0">
+                <a:solidFill>
+                  <a:srgbClr val="E2725B"/>
+                </a:solidFill>
+                <a:latin typeface="Microsoft YaHei" pitchFamily="34" charset="0"/>
+                <a:ea typeface="Microsoft YaHei" pitchFamily="34" charset="-122"/>
+                <a:cs typeface="Microsoft YaHei" pitchFamily="34" charset="-120"/>
+              </a:rPr>
+              <a:t>26-40 次</a:t>
+            </a:r>
+            <a:endParaRPr lang="en-US" sz="900" dirty="0"/>
+          </a:p>
+        </p:txBody>
+      </p:sp>
+      <p:sp>
+        <p:nvSpPr>
+          <p:cNvPr id="37" name="Text 35"/>
+          <p:cNvSpPr/>
+          <p:nvPr/>
+        </p:nvSpPr>
+        <p:spPr>
+          <a:xfrm>
+            <a:off x="6080760" y="2670048"/>
+            <a:ext cx="1234440" cy="274320"/>
+          </a:xfrm>
+          <a:prstGeom prst="rect">
+            <a:avLst/>
+          </a:prstGeom>
+          <a:noFill/>
+          <a:ln/>
+        </p:spPr>
+        <p:txBody>
+          <a:bodyPr wrap="square" rtlCol="0" anchor="ctr"/>
+          <a:lstStyle/>
+          <a:p>
+            <a:pPr indent="0" marL="0">
+              <a:buNone/>
+            </a:pPr>
+            <a:r>
+              <a:rPr lang="en-US" sz="1000" b="1" dirty="0">
+                <a:solidFill>
+                  <a:srgbClr val="1A2238"/>
+                </a:solidFill>
+                <a:latin typeface="Microsoft YaHei" pitchFamily="34" charset="0"/>
+                <a:ea typeface="Microsoft YaHei" pitchFamily="34" charset="-122"/>
+                <a:cs typeface="Microsoft YaHei" pitchFamily="34" charset="-120"/>
+              </a:rPr>
+              <a:t>三轴同步</a:t>
+            </a:r>
+            <a:endParaRPr lang="en-US" sz="1000" dirty="0"/>
+          </a:p>
+        </p:txBody>
+      </p:sp>
+      <p:sp>
+        <p:nvSpPr>
+          <p:cNvPr id="38" name="Text 36"/>
+          <p:cNvSpPr/>
+          <p:nvPr/>
+        </p:nvSpPr>
+        <p:spPr>
+          <a:xfrm>
+            <a:off x="6080760" y="2971800"/>
+            <a:ext cx="1234440" cy="1371600"/>
           </a:xfrm>
           <a:prstGeom prst="rect">
             <a:avLst/>
@@ -12276,196 +12717,341 @@
               <a:buNone/>
             </a:pPr>
             <a:r>
-              <a:rPr lang="en-US" sz="1200" b="1" dirty="0">
-                <a:solidFill>
-                  <a:srgbClr val="1A2238"/>
-                </a:solidFill>
-                <a:latin typeface="Microsoft YaHei" pitchFamily="34" charset="0"/>
-                <a:ea typeface="Microsoft YaHei" pitchFamily="34" charset="-122"/>
-                <a:cs typeface="Microsoft YaHei" pitchFamily="34" charset="-120"/>
-              </a:rPr>
-              <a:t>维护与成长</a:t>
-            </a:r>
-            <a:endParaRPr lang="en-US" sz="1200" dirty="0"/>
-          </a:p>
-        </p:txBody>
-      </p:sp>
-      <p:sp>
-        <p:nvSpPr>
-          <p:cNvPr id="36" name="Text 34"/>
-          <p:cNvSpPr/>
-          <p:nvPr/>
-        </p:nvSpPr>
-        <p:spPr>
-          <a:xfrm>
-            <a:off x="7315200" y="2697480"/>
-            <a:ext cx="1417320" cy="274320"/>
-          </a:xfrm>
-          <a:prstGeom prst="rect">
-            <a:avLst/>
-          </a:prstGeom>
-          <a:noFill/>
-          <a:ln/>
-        </p:spPr>
-        <p:txBody>
-          <a:bodyPr wrap="square" rtlCol="0" anchor="ctr"/>
-          <a:lstStyle/>
-          <a:p>
-            <a:pPr indent="0" marL="0">
-              <a:buNone/>
-            </a:pPr>
-            <a:r>
-              <a:rPr lang="en-US" sz="1000" dirty="0">
+              <a:rPr lang="en-US" sz="800" dirty="0">
+                <a:solidFill>
+                  <a:srgbClr val="4A5568"/>
+                </a:solidFill>
+                <a:latin typeface="Microsoft YaHei" pitchFamily="34" charset="0"/>
+                <a:ea typeface="Microsoft YaHei" pitchFamily="34" charset="-122"/>
+                <a:cs typeface="Microsoft YaHei" pitchFamily="34" charset="-120"/>
+              </a:rPr>
+              <a:t>三轴并用检验, 处理增长痛</a:t>
+            </a:r>
+            <a:endParaRPr lang="en-US" sz="800" dirty="0"/>
+          </a:p>
+        </p:txBody>
+      </p:sp>
+      <p:sp>
+        <p:nvSpPr>
+          <p:cNvPr id="39" name="Shape 37"/>
+          <p:cNvSpPr/>
+          <p:nvPr/>
+        </p:nvSpPr>
+        <p:spPr>
+          <a:xfrm>
+            <a:off x="7452360" y="1554480"/>
+            <a:ext cx="1325880" cy="2926080"/>
+          </a:xfrm>
+          <a:prstGeom prst="rect">
+            <a:avLst/>
+          </a:prstGeom>
+          <a:solidFill>
+            <a:srgbClr val="FFFFFF"/>
+          </a:solidFill>
+          <a:ln w="12700">
+            <a:solidFill>
+              <a:srgbClr val="D4C5B9"/>
+            </a:solidFill>
+            <a:prstDash val="solid"/>
+          </a:ln>
+        </p:spPr>
+      </p:sp>
+      <p:sp>
+        <p:nvSpPr>
+          <p:cNvPr id="40" name="Shape 38"/>
+          <p:cNvSpPr/>
+          <p:nvPr/>
+        </p:nvSpPr>
+        <p:spPr>
+          <a:xfrm>
+            <a:off x="7452360" y="1554480"/>
+            <a:ext cx="1325880" cy="365760"/>
+          </a:xfrm>
+          <a:prstGeom prst="rect">
+            <a:avLst/>
+          </a:prstGeom>
+          <a:solidFill>
+            <a:srgbClr val="1A2238"/>
+          </a:solidFill>
+          <a:ln/>
+        </p:spPr>
+      </p:sp>
+      <p:sp>
+        <p:nvSpPr>
+          <p:cNvPr id="41" name="Text 39"/>
+          <p:cNvSpPr/>
+          <p:nvPr/>
+        </p:nvSpPr>
+        <p:spPr>
+          <a:xfrm>
+            <a:off x="7452360" y="1600200"/>
+            <a:ext cx="1325880" cy="274320"/>
+          </a:xfrm>
+          <a:prstGeom prst="rect">
+            <a:avLst/>
+          </a:prstGeom>
+          <a:noFill/>
+          <a:ln/>
+        </p:spPr>
+        <p:txBody>
+          <a:bodyPr wrap="square" rtlCol="0" anchor="ctr"/>
+          <a:lstStyle/>
+          <a:p>
+            <a:pPr algn="ctr" indent="0" marL="0">
+              <a:buNone/>
+            </a:pPr>
+            <a:r>
+              <a:rPr lang="en-US" sz="1400" b="1" dirty="0">
                 <a:solidFill>
                   <a:srgbClr val="E2725B"/>
-                </a:solidFill>
-                <a:latin typeface="Microsoft YaHei" pitchFamily="34" charset="0"/>
-                <a:ea typeface="Microsoft YaHei" pitchFamily="34" charset="-122"/>
-                <a:cs typeface="Microsoft YaHei" pitchFamily="34" charset="-120"/>
-              </a:rPr>
-              <a:t>长期</a:t>
-            </a:r>
-            <a:endParaRPr lang="en-US" sz="1000" dirty="0"/>
-          </a:p>
-        </p:txBody>
-      </p:sp>
-      <p:sp>
-        <p:nvSpPr>
-          <p:cNvPr id="37" name="Text 35"/>
-          <p:cNvSpPr/>
-          <p:nvPr/>
-        </p:nvSpPr>
-        <p:spPr>
-          <a:xfrm>
-            <a:off x="7315200" y="3017520"/>
-            <a:ext cx="1417320" cy="1188720"/>
-          </a:xfrm>
-          <a:prstGeom prst="rect">
-            <a:avLst/>
-          </a:prstGeom>
-          <a:noFill/>
-          <a:ln/>
-        </p:spPr>
-        <p:txBody>
-          <a:bodyPr wrap="square" rtlCol="0" anchor="ctr"/>
-          <a:lstStyle/>
-          <a:p>
-            <a:pPr indent="0" marL="0">
-              <a:lnSpc>
-                <a:spcPct val="130000"/>
-              </a:lnSpc>
-              <a:buNone/>
-            </a:pPr>
-            <a:r>
-              <a:rPr lang="en-US" sz="900" dirty="0">
-                <a:solidFill>
-                  <a:srgbClr val="4A5568"/>
-                </a:solidFill>
-                <a:latin typeface="Microsoft YaHei" pitchFamily="34" charset="0"/>
-                <a:ea typeface="Microsoft YaHei" pitchFamily="34" charset="-122"/>
-                <a:cs typeface="Microsoft YaHei" pitchFamily="34" charset="-120"/>
-              </a:rPr>
-              <a:t>巩固整合, 处理成长痛, 转向自我主导</a:t>
-            </a:r>
-            <a:endParaRPr lang="en-US" sz="900" dirty="0"/>
-          </a:p>
-        </p:txBody>
-      </p:sp>
-      <p:sp>
-        <p:nvSpPr>
-          <p:cNvPr id="38" name="Shape 36"/>
-          <p:cNvSpPr/>
-          <p:nvPr/>
-        </p:nvSpPr>
-        <p:spPr>
-          <a:xfrm>
-            <a:off x="457200" y="4434840"/>
-            <a:ext cx="8229600" cy="274320"/>
-          </a:xfrm>
-          <a:prstGeom prst="rect">
-            <a:avLst/>
-          </a:prstGeom>
-          <a:solidFill>
-            <a:srgbClr val="FAF6F1"/>
-          </a:solidFill>
-          <a:ln/>
-        </p:spPr>
-      </p:sp>
-      <p:sp>
-        <p:nvSpPr>
-          <p:cNvPr id="39" name="Text 37"/>
-          <p:cNvSpPr/>
-          <p:nvPr/>
-        </p:nvSpPr>
-        <p:spPr>
-          <a:xfrm>
-            <a:off x="640080" y="4434840"/>
-            <a:ext cx="7863840" cy="274320"/>
-          </a:xfrm>
-          <a:prstGeom prst="rect">
-            <a:avLst/>
-          </a:prstGeom>
-          <a:noFill/>
-          <a:ln/>
-        </p:spPr>
-        <p:txBody>
-          <a:bodyPr wrap="square" rtlCol="0" anchor="ctr"/>
-          <a:lstStyle/>
-          <a:p>
-            <a:pPr indent="0" marL="0">
-              <a:buNone/>
-            </a:pPr>
-            <a:r>
-              <a:rPr lang="en-US" sz="1100" i="1" dirty="0">
-                <a:solidFill>
-                  <a:srgbClr val="4A5568"/>
-                </a:solidFill>
-                <a:latin typeface="Microsoft YaHei" pitchFamily="34" charset="0"/>
-                <a:ea typeface="Microsoft YaHei" pitchFamily="34" charset="-122"/>
-                <a:cs typeface="Microsoft YaHei" pitchFamily="34" charset="-120"/>
-              </a:rPr>
-              <a:t>原则: 触碰核心恐惧前,先确保安全基地够稳——顺序颠倒会复制早年创伤而非修复</a:t>
-            </a:r>
-            <a:endParaRPr lang="en-US" sz="1100" dirty="0"/>
-          </a:p>
-        </p:txBody>
-      </p:sp>
-      <p:sp>
-        <p:nvSpPr>
-          <p:cNvPr id="40" name="Text 38"/>
-          <p:cNvSpPr/>
-          <p:nvPr/>
-        </p:nvSpPr>
-        <p:spPr>
-          <a:xfrm>
-            <a:off x="8503920" y="4663440"/>
-            <a:ext cx="457200" cy="274320"/>
-          </a:xfrm>
-          <a:prstGeom prst="rect">
-            <a:avLst/>
-          </a:prstGeom>
-          <a:noFill/>
-          <a:ln/>
-        </p:spPr>
-        <p:txBody>
-          <a:bodyPr wrap="square" rtlCol="0" anchor="ctr"/>
-          <a:lstStyle/>
-          <a:p>
-            <a:pPr algn="r" indent="0" marL="0">
-              <a:buNone/>
-            </a:pPr>
-            <a:r>
-              <a:rPr lang="en-US" sz="1000" dirty="0">
-                <a:solidFill>
-                  <a:srgbClr val="4A5568"/>
                 </a:solidFill>
                 <a:latin typeface="Arial" pitchFamily="34" charset="0"/>
                 <a:ea typeface="Arial" pitchFamily="34" charset="-122"/>
                 <a:cs typeface="Arial" pitchFamily="34" charset="-120"/>
               </a:rPr>
-              <a:t>17</a:t>
+              <a:t>06</a:t>
+            </a:r>
+            <a:endParaRPr lang="en-US" sz="1400" dirty="0"/>
+          </a:p>
+        </p:txBody>
+      </p:sp>
+      <p:sp>
+        <p:nvSpPr>
+          <p:cNvPr id="42" name="Text 40"/>
+          <p:cNvSpPr/>
+          <p:nvPr/>
+        </p:nvSpPr>
+        <p:spPr>
+          <a:xfrm>
+            <a:off x="7498080" y="1993392"/>
+            <a:ext cx="1234440" cy="411480"/>
+          </a:xfrm>
+          <a:prstGeom prst="rect">
+            <a:avLst/>
+          </a:prstGeom>
+          <a:noFill/>
+          <a:ln/>
+        </p:spPr>
+        <p:txBody>
+          <a:bodyPr wrap="square" rtlCol="0" anchor="ctr"/>
+          <a:lstStyle/>
+          <a:p>
+            <a:pPr indent="0" marL="0">
+              <a:lnSpc>
+                <a:spcPct val="110000"/>
+              </a:lnSpc>
+              <a:buNone/>
+            </a:pPr>
+            <a:r>
+              <a:rPr lang="en-US" sz="1200" b="1" dirty="0">
+                <a:solidFill>
+                  <a:srgbClr val="1A2238"/>
+                </a:solidFill>
+                <a:latin typeface="Microsoft YaHei" pitchFamily="34" charset="0"/>
+                <a:ea typeface="Microsoft YaHei" pitchFamily="34" charset="-122"/>
+                <a:cs typeface="Microsoft YaHei" pitchFamily="34" charset="-120"/>
+              </a:rPr>
+              <a:t>维护结案</a:t>
+            </a:r>
+            <a:endParaRPr lang="en-US" sz="1200" dirty="0"/>
+          </a:p>
+        </p:txBody>
+      </p:sp>
+      <p:sp>
+        <p:nvSpPr>
+          <p:cNvPr id="43" name="Text 41"/>
+          <p:cNvSpPr/>
+          <p:nvPr/>
+        </p:nvSpPr>
+        <p:spPr>
+          <a:xfrm>
+            <a:off x="7498080" y="2423160"/>
+            <a:ext cx="1234440" cy="228600"/>
+          </a:xfrm>
+          <a:prstGeom prst="rect">
+            <a:avLst/>
+          </a:prstGeom>
+          <a:noFill/>
+          <a:ln/>
+        </p:spPr>
+        <p:txBody>
+          <a:bodyPr wrap="square" rtlCol="0" anchor="ctr"/>
+          <a:lstStyle/>
+          <a:p>
+            <a:pPr indent="0" marL="0">
+              <a:buNone/>
+            </a:pPr>
+            <a:r>
+              <a:rPr lang="en-US" sz="900" dirty="0">
+                <a:solidFill>
+                  <a:srgbClr val="E2725B"/>
+                </a:solidFill>
+                <a:latin typeface="Microsoft YaHei" pitchFamily="34" charset="0"/>
+                <a:ea typeface="Microsoft YaHei" pitchFamily="34" charset="-122"/>
+                <a:cs typeface="Microsoft YaHei" pitchFamily="34" charset="-120"/>
+              </a:rPr>
+              <a:t>长期</a:t>
+            </a:r>
+            <a:endParaRPr lang="en-US" sz="900" dirty="0"/>
+          </a:p>
+        </p:txBody>
+      </p:sp>
+      <p:sp>
+        <p:nvSpPr>
+          <p:cNvPr id="44" name="Text 42"/>
+          <p:cNvSpPr/>
+          <p:nvPr/>
+        </p:nvSpPr>
+        <p:spPr>
+          <a:xfrm>
+            <a:off x="7498080" y="2670048"/>
+            <a:ext cx="1234440" cy="274320"/>
+          </a:xfrm>
+          <a:prstGeom prst="rect">
+            <a:avLst/>
+          </a:prstGeom>
+          <a:noFill/>
+          <a:ln/>
+        </p:spPr>
+        <p:txBody>
+          <a:bodyPr wrap="square" rtlCol="0" anchor="ctr"/>
+          <a:lstStyle/>
+          <a:p>
+            <a:pPr indent="0" marL="0">
+              <a:buNone/>
+            </a:pPr>
+            <a:r>
+              <a:rPr lang="en-US" sz="1000" b="1" dirty="0">
+                <a:solidFill>
+                  <a:srgbClr val="1A2238"/>
+                </a:solidFill>
+                <a:latin typeface="Microsoft YaHei" pitchFamily="34" charset="0"/>
+                <a:ea typeface="Microsoft YaHei" pitchFamily="34" charset="-122"/>
+                <a:cs typeface="Microsoft YaHei" pitchFamily="34" charset="-120"/>
+              </a:rPr>
+              <a:t>三轴并用</a:t>
             </a:r>
             <a:endParaRPr lang="en-US" sz="1000" dirty="0"/>
+          </a:p>
+        </p:txBody>
+      </p:sp>
+      <p:sp>
+        <p:nvSpPr>
+          <p:cNvPr id="45" name="Text 43"/>
+          <p:cNvSpPr/>
+          <p:nvPr/>
+        </p:nvSpPr>
+        <p:spPr>
+          <a:xfrm>
+            <a:off x="7498080" y="2971800"/>
+            <a:ext cx="1234440" cy="1371600"/>
+          </a:xfrm>
+          <a:prstGeom prst="rect">
+            <a:avLst/>
+          </a:prstGeom>
+          <a:noFill/>
+          <a:ln/>
+        </p:spPr>
+        <p:txBody>
+          <a:bodyPr wrap="square" rtlCol="0" anchor="ctr"/>
+          <a:lstStyle/>
+          <a:p>
+            <a:pPr indent="0" marL="0">
+              <a:lnSpc>
+                <a:spcPct val="120000"/>
+              </a:lnSpc>
+              <a:buNone/>
+            </a:pPr>
+            <a:r>
+              <a:rPr lang="en-US" sz="800" dirty="0">
+                <a:solidFill>
+                  <a:srgbClr val="4A5568"/>
+                </a:solidFill>
+                <a:latin typeface="Microsoft YaHei" pitchFamily="34" charset="0"/>
+                <a:ea typeface="Microsoft YaHei" pitchFamily="34" charset="-122"/>
+                <a:cs typeface="Microsoft YaHei" pitchFamily="34" charset="-120"/>
+              </a:rPr>
+              <a:t>渐退频率, 内化咨询师</a:t>
+            </a:r>
+            <a:endParaRPr lang="en-US" sz="800" dirty="0"/>
+          </a:p>
+        </p:txBody>
+      </p:sp>
+      <p:sp>
+        <p:nvSpPr>
+          <p:cNvPr id="46" name="Text 44"/>
+          <p:cNvSpPr/>
+          <p:nvPr/>
+        </p:nvSpPr>
+        <p:spPr>
+          <a:xfrm>
+            <a:off x="365760" y="4663440"/>
+            <a:ext cx="8412480" cy="365760"/>
+          </a:xfrm>
+          <a:prstGeom prst="rect">
+            <a:avLst/>
+          </a:prstGeom>
+          <a:noFill/>
+          <a:ln/>
+        </p:spPr>
+        <p:txBody>
+          <a:bodyPr wrap="square" rtlCol="0" anchor="ctr"/>
+          <a:lstStyle/>
+          <a:p>
+            <a:pPr algn="ctr" indent="0" marL="0">
+              <a:buNone/>
+            </a:pPr>
+            <a:r>
+              <a:rPr lang="en-US" sz="1100" i="1" dirty="0">
+                <a:solidFill>
+                  <a:srgbClr val="1A2238"/>
+                </a:solidFill>
+                <a:latin typeface="Microsoft YaHei" pitchFamily="34" charset="0"/>
+                <a:ea typeface="Microsoft YaHei" pitchFamily="34" charset="-122"/>
+                <a:cs typeface="Microsoft YaHei" pitchFamily="34" charset="-120"/>
+              </a:rPr>
+              <a:t>三轴递进路径(身体层→动力层→结构层), 主轴从依恋逐级到三轴并用, 缺一不可</a:t>
+            </a:r>
+            <a:endParaRPr lang="en-US" sz="1100" dirty="0"/>
+          </a:p>
+        </p:txBody>
+      </p:sp>
+      <p:sp>
+        <p:nvSpPr>
+          <p:cNvPr id="47" name="Text 45"/>
+          <p:cNvSpPr/>
+          <p:nvPr/>
+        </p:nvSpPr>
+        <p:spPr>
+          <a:xfrm>
+            <a:off x="5943600" y="4892040"/>
+            <a:ext cx="2743200" cy="228600"/>
+          </a:xfrm>
+          <a:prstGeom prst="rect">
+            <a:avLst/>
+          </a:prstGeom>
+          <a:noFill/>
+          <a:ln/>
+        </p:spPr>
+        <p:txBody>
+          <a:bodyPr wrap="square" rtlCol="0" anchor="ctr"/>
+          <a:lstStyle/>
+          <a:p>
+            <a:pPr algn="r" indent="0" marL="0">
+              <a:buNone/>
+            </a:pPr>
+            <a:r>
+              <a:rPr lang="en-US" sz="900" dirty="0">
+                <a:solidFill>
+                  <a:srgbClr val="E2725B"/>
+                </a:solidFill>
+                <a:latin typeface="Microsoft YaHei" pitchFamily="34" charset="0"/>
+                <a:ea typeface="Microsoft YaHei" pitchFamily="34" charset="-122"/>
+                <a:cs typeface="Microsoft YaHei" pitchFamily="34" charset="-120"/>
+              </a:rPr>
+              <a:t>一念三轴 · Yiinian Triaxis (v2.2)</a:t>
+            </a:r>
+            <a:endParaRPr lang="en-US" sz="900" dirty="0"/>
           </a:p>
         </p:txBody>
       </p:sp>
@@ -13434,6 +14020,45 @@
           </a:p>
         </p:txBody>
       </p:sp>
+      <p:sp>
+        <p:nvSpPr>
+          <p:cNvPr id="29" name="Text 27"/>
+          <p:cNvSpPr/>
+          <p:nvPr/>
+        </p:nvSpPr>
+        <p:spPr>
+          <a:xfrm>
+            <a:off x="5943600" y="4892040"/>
+            <a:ext cx="2743200" cy="228600"/>
+          </a:xfrm>
+          <a:prstGeom prst="rect">
+            <a:avLst/>
+          </a:prstGeom>
+          <a:noFill/>
+          <a:ln/>
+        </p:spPr>
+        <p:txBody>
+          <a:bodyPr wrap="square" rtlCol="0" anchor="ctr"/>
+          <a:lstStyle/>
+          <a:p>
+            <a:pPr algn="r" indent="0" marL="0">
+              <a:buNone/>
+            </a:pPr>
+            <a:r>
+              <a:rPr lang="en-US" sz="900" dirty="0">
+                <a:solidFill>
+                  <a:srgbClr val="E2725B"/>
+                </a:solidFill>
+                <a:latin typeface="Microsoft YaHei" pitchFamily="34" charset="0"/>
+                <a:ea typeface="Microsoft YaHei" pitchFamily="34" charset="-122"/>
+                <a:cs typeface="Microsoft YaHei" pitchFamily="34" charset="-120"/>
+              </a:rPr>
+              <a:t>一念三轴 · Yiinian Triaxis (v2.2)</a:t>
+            </a:r>
+            <a:endParaRPr lang="en-US" sz="900" dirty="0"/>
+          </a:p>
+        </p:txBody>
+      </p:sp>
     </p:spTree>
   </p:cSld>
   <p:clrMapOvr>
@@ -13681,6 +14306,45 @@
           </a:p>
         </p:txBody>
       </p:sp>
+      <p:sp>
+        <p:nvSpPr>
+          <p:cNvPr id="8" name="Text 6"/>
+          <p:cNvSpPr/>
+          <p:nvPr/>
+        </p:nvSpPr>
+        <p:spPr>
+          <a:xfrm>
+            <a:off x="5943600" y="4892040"/>
+            <a:ext cx="2743200" cy="228600"/>
+          </a:xfrm>
+          <a:prstGeom prst="rect">
+            <a:avLst/>
+          </a:prstGeom>
+          <a:noFill/>
+          <a:ln/>
+        </p:spPr>
+        <p:txBody>
+          <a:bodyPr wrap="square" rtlCol="0" anchor="ctr"/>
+          <a:lstStyle/>
+          <a:p>
+            <a:pPr algn="r" indent="0" marL="0">
+              <a:buNone/>
+            </a:pPr>
+            <a:r>
+              <a:rPr lang="en-US" sz="900" dirty="0">
+                <a:solidFill>
+                  <a:srgbClr val="E2725B"/>
+                </a:solidFill>
+                <a:latin typeface="Microsoft YaHei" pitchFamily="34" charset="0"/>
+                <a:ea typeface="Microsoft YaHei" pitchFamily="34" charset="-122"/>
+                <a:cs typeface="Microsoft YaHei" pitchFamily="34" charset="-120"/>
+              </a:rPr>
+              <a:t>一念三轴 · Yiinian Triaxis (v2.2)</a:t>
+            </a:r>
+            <a:endParaRPr lang="en-US" sz="900" dirty="0"/>
+          </a:p>
+        </p:txBody>
+      </p:sp>
     </p:spTree>
   </p:cSld>
   <p:clrMapOvr>
@@ -14333,7 +14997,7 @@
                 <a:ea typeface="Microsoft YaHei" pitchFamily="34" charset="-122"/>
                 <a:cs typeface="Microsoft YaHei" pitchFamily="34" charset="-120"/>
               </a:rPr>
-              <a:t>五阶段流程 · 核心技术</a:t>
+              <a:t>6 阶段流程 · 11 核心技术</a:t>
             </a:r>
             <a:endParaRPr lang="en-US" sz="1100" dirty="0"/>
           </a:p>
@@ -15527,6 +16191,45 @@
           </a:p>
         </p:txBody>
       </p:sp>
+      <p:sp>
+        <p:nvSpPr>
+          <p:cNvPr id="26" name="Text 24"/>
+          <p:cNvSpPr/>
+          <p:nvPr/>
+        </p:nvSpPr>
+        <p:spPr>
+          <a:xfrm>
+            <a:off x="5943600" y="4892040"/>
+            <a:ext cx="2743200" cy="228600"/>
+          </a:xfrm>
+          <a:prstGeom prst="rect">
+            <a:avLst/>
+          </a:prstGeom>
+          <a:noFill/>
+          <a:ln/>
+        </p:spPr>
+        <p:txBody>
+          <a:bodyPr wrap="square" rtlCol="0" anchor="ctr"/>
+          <a:lstStyle/>
+          <a:p>
+            <a:pPr algn="r" indent="0" marL="0">
+              <a:buNone/>
+            </a:pPr>
+            <a:r>
+              <a:rPr lang="en-US" sz="900" dirty="0">
+                <a:solidFill>
+                  <a:srgbClr val="E2725B"/>
+                </a:solidFill>
+                <a:latin typeface="Microsoft YaHei" pitchFamily="34" charset="0"/>
+                <a:ea typeface="Microsoft YaHei" pitchFamily="34" charset="-122"/>
+                <a:cs typeface="Microsoft YaHei" pitchFamily="34" charset="-120"/>
+              </a:rPr>
+              <a:t>一念三轴 · Yiinian Triaxis (v2.2)</a:t>
+            </a:r>
+            <a:endParaRPr lang="en-US" sz="900" dirty="0"/>
+          </a:p>
+        </p:txBody>
+      </p:sp>
     </p:spTree>
   </p:cSld>
   <p:clrMapOvr>
@@ -16363,6 +17066,45 @@
           </a:p>
         </p:txBody>
       </p:sp>
+      <p:sp>
+        <p:nvSpPr>
+          <p:cNvPr id="26" name="Text 24"/>
+          <p:cNvSpPr/>
+          <p:nvPr/>
+        </p:nvSpPr>
+        <p:spPr>
+          <a:xfrm>
+            <a:off x="5943600" y="4892040"/>
+            <a:ext cx="2743200" cy="228600"/>
+          </a:xfrm>
+          <a:prstGeom prst="rect">
+            <a:avLst/>
+          </a:prstGeom>
+          <a:noFill/>
+          <a:ln/>
+        </p:spPr>
+        <p:txBody>
+          <a:bodyPr wrap="square" rtlCol="0" anchor="ctr"/>
+          <a:lstStyle/>
+          <a:p>
+            <a:pPr algn="r" indent="0" marL="0">
+              <a:buNone/>
+            </a:pPr>
+            <a:r>
+              <a:rPr lang="en-US" sz="900" dirty="0">
+                <a:solidFill>
+                  <a:srgbClr val="E2725B"/>
+                </a:solidFill>
+                <a:latin typeface="Microsoft YaHei" pitchFamily="34" charset="0"/>
+                <a:ea typeface="Microsoft YaHei" pitchFamily="34" charset="-122"/>
+                <a:cs typeface="Microsoft YaHei" pitchFamily="34" charset="-120"/>
+              </a:rPr>
+              <a:t>一念三轴 · Yiinian Triaxis (v2.2)</a:t>
+            </a:r>
+            <a:endParaRPr lang="en-US" sz="900" dirty="0"/>
+          </a:p>
+        </p:txBody>
+      </p:sp>
     </p:spTree>
   </p:cSld>
   <p:clrMapOvr>
@@ -17199,6 +17941,45 @@
           </a:p>
         </p:txBody>
       </p:sp>
+      <p:sp>
+        <p:nvSpPr>
+          <p:cNvPr id="26" name="Text 24"/>
+          <p:cNvSpPr/>
+          <p:nvPr/>
+        </p:nvSpPr>
+        <p:spPr>
+          <a:xfrm>
+            <a:off x="5943600" y="4892040"/>
+            <a:ext cx="2743200" cy="228600"/>
+          </a:xfrm>
+          <a:prstGeom prst="rect">
+            <a:avLst/>
+          </a:prstGeom>
+          <a:noFill/>
+          <a:ln/>
+        </p:spPr>
+        <p:txBody>
+          <a:bodyPr wrap="square" rtlCol="0" anchor="ctr"/>
+          <a:lstStyle/>
+          <a:p>
+            <a:pPr algn="r" indent="0" marL="0">
+              <a:buNone/>
+            </a:pPr>
+            <a:r>
+              <a:rPr lang="en-US" sz="900" dirty="0">
+                <a:solidFill>
+                  <a:srgbClr val="E2725B"/>
+                </a:solidFill>
+                <a:latin typeface="Microsoft YaHei" pitchFamily="34" charset="0"/>
+                <a:ea typeface="Microsoft YaHei" pitchFamily="34" charset="-122"/>
+                <a:cs typeface="Microsoft YaHei" pitchFamily="34" charset="-120"/>
+              </a:rPr>
+              <a:t>一念三轴 · Yiinian Triaxis (v2.2)</a:t>
+            </a:r>
+            <a:endParaRPr lang="en-US" sz="900" dirty="0"/>
+          </a:p>
+        </p:txBody>
+      </p:sp>
     </p:spTree>
   </p:cSld>
   <p:clrMapOvr>
@@ -17446,6 +18227,45 @@
           </a:p>
         </p:txBody>
       </p:sp>
+      <p:sp>
+        <p:nvSpPr>
+          <p:cNvPr id="8" name="Text 6"/>
+          <p:cNvSpPr/>
+          <p:nvPr/>
+        </p:nvSpPr>
+        <p:spPr>
+          <a:xfrm>
+            <a:off x="5943600" y="4892040"/>
+            <a:ext cx="2743200" cy="228600"/>
+          </a:xfrm>
+          <a:prstGeom prst="rect">
+            <a:avLst/>
+          </a:prstGeom>
+          <a:noFill/>
+          <a:ln/>
+        </p:spPr>
+        <p:txBody>
+          <a:bodyPr wrap="square" rtlCol="0" anchor="ctr"/>
+          <a:lstStyle/>
+          <a:p>
+            <a:pPr algn="r" indent="0" marL="0">
+              <a:buNone/>
+            </a:pPr>
+            <a:r>
+              <a:rPr lang="en-US" sz="900" dirty="0">
+                <a:solidFill>
+                  <a:srgbClr val="E2725B"/>
+                </a:solidFill>
+                <a:latin typeface="Microsoft YaHei" pitchFamily="34" charset="0"/>
+                <a:ea typeface="Microsoft YaHei" pitchFamily="34" charset="-122"/>
+                <a:cs typeface="Microsoft YaHei" pitchFamily="34" charset="-120"/>
+              </a:rPr>
+              <a:t>一念三轴 · Yiinian Triaxis (v2.2)</a:t>
+            </a:r>
+            <a:endParaRPr lang="en-US" sz="900" dirty="0"/>
+          </a:p>
+        </p:txBody>
+      </p:sp>
     </p:spTree>
   </p:cSld>
   <p:clrMapOvr>
@@ -18504,6 +19324,45 @@
           </a:p>
         </p:txBody>
       </p:sp>
+      <p:sp>
+        <p:nvSpPr>
+          <p:cNvPr id="35" name="Text 33"/>
+          <p:cNvSpPr/>
+          <p:nvPr/>
+        </p:nvSpPr>
+        <p:spPr>
+          <a:xfrm>
+            <a:off x="5943600" y="4892040"/>
+            <a:ext cx="2743200" cy="228600"/>
+          </a:xfrm>
+          <a:prstGeom prst="rect">
+            <a:avLst/>
+          </a:prstGeom>
+          <a:noFill/>
+          <a:ln/>
+        </p:spPr>
+        <p:txBody>
+          <a:bodyPr wrap="square" rtlCol="0" anchor="ctr"/>
+          <a:lstStyle/>
+          <a:p>
+            <a:pPr algn="r" indent="0" marL="0">
+              <a:buNone/>
+            </a:pPr>
+            <a:r>
+              <a:rPr lang="en-US" sz="900" dirty="0">
+                <a:solidFill>
+                  <a:srgbClr val="E2725B"/>
+                </a:solidFill>
+                <a:latin typeface="Microsoft YaHei" pitchFamily="34" charset="0"/>
+                <a:ea typeface="Microsoft YaHei" pitchFamily="34" charset="-122"/>
+                <a:cs typeface="Microsoft YaHei" pitchFamily="34" charset="-120"/>
+              </a:rPr>
+              <a:t>一念三轴 · Yiinian Triaxis (v2.2)</a:t>
+            </a:r>
+            <a:endParaRPr lang="en-US" sz="900" dirty="0"/>
+          </a:p>
+        </p:txBody>
+      </p:sp>
     </p:spTree>
   </p:cSld>
   <p:clrMapOvr>
@@ -19267,6 +20126,45 @@
           </a:p>
         </p:txBody>
       </p:sp>
+      <p:sp>
+        <p:nvSpPr>
+          <p:cNvPr id="22" name="Text 20"/>
+          <p:cNvSpPr/>
+          <p:nvPr/>
+        </p:nvSpPr>
+        <p:spPr>
+          <a:xfrm>
+            <a:off x="5943600" y="4892040"/>
+            <a:ext cx="2743200" cy="228600"/>
+          </a:xfrm>
+          <a:prstGeom prst="rect">
+            <a:avLst/>
+          </a:prstGeom>
+          <a:noFill/>
+          <a:ln/>
+        </p:spPr>
+        <p:txBody>
+          <a:bodyPr wrap="square" rtlCol="0" anchor="ctr"/>
+          <a:lstStyle/>
+          <a:p>
+            <a:pPr algn="r" indent="0" marL="0">
+              <a:buNone/>
+            </a:pPr>
+            <a:r>
+              <a:rPr lang="en-US" sz="900" dirty="0">
+                <a:solidFill>
+                  <a:srgbClr val="E2725B"/>
+                </a:solidFill>
+                <a:latin typeface="Microsoft YaHei" pitchFamily="34" charset="0"/>
+                <a:ea typeface="Microsoft YaHei" pitchFamily="34" charset="-122"/>
+                <a:cs typeface="Microsoft YaHei" pitchFamily="34" charset="-120"/>
+              </a:rPr>
+              <a:t>一念三轴 · Yiinian Triaxis (v2.2)</a:t>
+            </a:r>
+            <a:endParaRPr lang="en-US" sz="900" dirty="0"/>
+          </a:p>
+        </p:txBody>
+      </p:sp>
     </p:spTree>
   </p:cSld>
   <p:clrMapOvr>
@@ -19784,6 +20682,2035 @@
               <a:t>26</a:t>
             </a:r>
             <a:endParaRPr lang="en-US" sz="1000" dirty="0"/>
+          </a:p>
+        </p:txBody>
+      </p:sp>
+      <p:sp>
+        <p:nvSpPr>
+          <p:cNvPr id="15" name="Text 13"/>
+          <p:cNvSpPr/>
+          <p:nvPr/>
+        </p:nvSpPr>
+        <p:spPr>
+          <a:xfrm>
+            <a:off x="5943600" y="4892040"/>
+            <a:ext cx="2743200" cy="228600"/>
+          </a:xfrm>
+          <a:prstGeom prst="rect">
+            <a:avLst/>
+          </a:prstGeom>
+          <a:noFill/>
+          <a:ln/>
+        </p:spPr>
+        <p:txBody>
+          <a:bodyPr wrap="square" rtlCol="0" anchor="ctr"/>
+          <a:lstStyle/>
+          <a:p>
+            <a:pPr algn="r" indent="0" marL="0">
+              <a:buNone/>
+            </a:pPr>
+            <a:r>
+              <a:rPr lang="en-US" sz="900" dirty="0">
+                <a:solidFill>
+                  <a:srgbClr val="E2725B"/>
+                </a:solidFill>
+                <a:latin typeface="Microsoft YaHei" pitchFamily="34" charset="0"/>
+                <a:ea typeface="Microsoft YaHei" pitchFamily="34" charset="-122"/>
+                <a:cs typeface="Microsoft YaHei" pitchFamily="34" charset="-120"/>
+              </a:rPr>
+              <a:t>一念三轴 · Yiinian Triaxis (v2.2)</a:t>
+            </a:r>
+            <a:endParaRPr lang="en-US" sz="900" dirty="0"/>
+          </a:p>
+        </p:txBody>
+      </p:sp>
+    </p:spTree>
+  </p:cSld>
+  <p:clrMapOvr>
+    <a:masterClrMapping/>
+  </p:clrMapOvr>
+</p:sld>
+</file>
+
+<file path=ppt/slides/slide27.xml><?xml version="1.0" encoding="utf-8"?>
+<p:sld xmlns:a="http://schemas.openxmlformats.org/drawingml/2006/main" xmlns:r="http://schemas.openxmlformats.org/officeDocument/2006/relationships" xmlns:p="http://schemas.openxmlformats.org/presentationml/2006/main">
+  <p:cSld name="Slide 27">
+    <p:bg>
+      <p:bgPr>
+        <a:solidFill>
+          <a:srgbClr val="FAF6F1"/>
+        </a:solidFill>
+      </p:bgPr>
+    </p:bg>
+    <p:spTree>
+      <p:nvGrpSpPr>
+        <p:cNvPr id="1" name=""/>
+        <p:cNvGrpSpPr/>
+        <p:nvPr/>
+      </p:nvGrpSpPr>
+      <p:grpSpPr>
+        <a:xfrm>
+          <a:off x="0" y="0"/>
+          <a:ext cx="0" cy="0"/>
+          <a:chOff x="0" y="0"/>
+          <a:chExt cx="0" cy="0"/>
+        </a:xfrm>
+      </p:grpSpPr>
+      <p:sp>
+        <p:nvSpPr>
+          <p:cNvPr id="2" name="Text 0"/>
+          <p:cNvSpPr/>
+          <p:nvPr/>
+        </p:nvSpPr>
+        <p:spPr>
+          <a:xfrm>
+            <a:off x="457200" y="365760"/>
+            <a:ext cx="8229600" cy="548640"/>
+          </a:xfrm>
+          <a:prstGeom prst="rect">
+            <a:avLst/>
+          </a:prstGeom>
+          <a:noFill/>
+          <a:ln/>
+        </p:spPr>
+        <p:txBody>
+          <a:bodyPr wrap="square" rtlCol="0" anchor="ctr"/>
+          <a:lstStyle/>
+          <a:p>
+            <a:pPr indent="0" marL="0">
+              <a:buNone/>
+            </a:pPr>
+            <a:r>
+              <a:rPr lang="en-US" sz="3000" b="1" dirty="0">
+                <a:solidFill>
+                  <a:srgbClr val="1A2238"/>
+                </a:solidFill>
+                <a:latin typeface="Microsoft YaHei" pitchFamily="34" charset="0"/>
+                <a:ea typeface="Microsoft YaHei" pitchFamily="34" charset="-122"/>
+                <a:cs typeface="Microsoft YaHei" pitchFamily="34" charset="-120"/>
+              </a:rPr>
+              <a:t>3 防御位 × 12 构型</a:t>
+            </a:r>
+            <a:endParaRPr lang="en-US" sz="3000" dirty="0"/>
+          </a:p>
+        </p:txBody>
+      </p:sp>
+      <p:sp>
+        <p:nvSpPr>
+          <p:cNvPr id="3" name="Text 1"/>
+          <p:cNvSpPr/>
+          <p:nvPr/>
+        </p:nvSpPr>
+        <p:spPr>
+          <a:xfrm>
+            <a:off x="457200" y="914400"/>
+            <a:ext cx="8229600" cy="274320"/>
+          </a:xfrm>
+          <a:prstGeom prst="rect">
+            <a:avLst/>
+          </a:prstGeom>
+          <a:noFill/>
+          <a:ln/>
+        </p:spPr>
+        <p:txBody>
+          <a:bodyPr wrap="square" rtlCol="0" anchor="ctr"/>
+          <a:lstStyle/>
+          <a:p>
+            <a:pPr indent="0" marL="0">
+              <a:buNone/>
+            </a:pPr>
+            <a:r>
+              <a:rPr lang="en-US" sz="1200" i="1" spc="300" kern="0" dirty="0">
+                <a:solidFill>
+                  <a:srgbClr val="E2725B"/>
+                </a:solidFill>
+                <a:latin typeface="Arial" pitchFamily="34" charset="0"/>
+                <a:ea typeface="Arial" pitchFamily="34" charset="-122"/>
+                <a:cs typeface="Arial" pitchFamily="34" charset="-120"/>
+              </a:rPr>
+              <a:t>3 Defense Positions × 4 Attachment = 12 Configurations (v2.2 新增)</a:t>
+            </a:r>
+            <a:endParaRPr lang="en-US" sz="1200" dirty="0"/>
+          </a:p>
+        </p:txBody>
+      </p:sp>
+      <p:sp>
+        <p:nvSpPr>
+          <p:cNvPr id="4" name="Text 2"/>
+          <p:cNvSpPr/>
+          <p:nvPr/>
+        </p:nvSpPr>
+        <p:spPr>
+          <a:xfrm>
+            <a:off x="457200" y="1463040"/>
+            <a:ext cx="4114800" cy="320040"/>
+          </a:xfrm>
+          <a:prstGeom prst="rect">
+            <a:avLst/>
+          </a:prstGeom>
+          <a:noFill/>
+          <a:ln/>
+        </p:spPr>
+        <p:txBody>
+          <a:bodyPr wrap="square" rtlCol="0" anchor="ctr"/>
+          <a:lstStyle/>
+          <a:p>
+            <a:pPr indent="0" marL="0">
+              <a:buNone/>
+            </a:pPr>
+            <a:r>
+              <a:rPr lang="en-US" sz="1400" b="1" dirty="0">
+                <a:solidFill>
+                  <a:srgbClr val="E2725B"/>
+                </a:solidFill>
+                <a:latin typeface="Microsoft YaHei" pitchFamily="34" charset="0"/>
+                <a:ea typeface="Microsoft YaHei" pitchFamily="34" charset="-122"/>
+                <a:cs typeface="Microsoft YaHei" pitchFamily="34" charset="-120"/>
+              </a:rPr>
+              <a:t>3 个防御位 (从 9 个九型简化)</a:t>
+            </a:r>
+            <a:endParaRPr lang="en-US" sz="1400" dirty="0"/>
+          </a:p>
+        </p:txBody>
+      </p:sp>
+      <p:sp>
+        <p:nvSpPr>
+          <p:cNvPr id="5" name="Shape 3"/>
+          <p:cNvSpPr/>
+          <p:nvPr/>
+        </p:nvSpPr>
+        <p:spPr>
+          <a:xfrm>
+            <a:off x="457200" y="1874520"/>
+            <a:ext cx="4114800" cy="594360"/>
+          </a:xfrm>
+          <a:prstGeom prst="rect">
+            <a:avLst/>
+          </a:prstGeom>
+          <a:solidFill>
+            <a:srgbClr val="FFFFFF"/>
+          </a:solidFill>
+          <a:ln w="12700">
+            <a:solidFill>
+              <a:srgbClr val="D4C5B9"/>
+            </a:solidFill>
+            <a:prstDash val="solid"/>
+          </a:ln>
+        </p:spPr>
+      </p:sp>
+      <p:sp>
+        <p:nvSpPr>
+          <p:cNvPr id="6" name="Shape 4"/>
+          <p:cNvSpPr/>
+          <p:nvPr/>
+        </p:nvSpPr>
+        <p:spPr>
+          <a:xfrm>
+            <a:off x="457200" y="1874520"/>
+            <a:ext cx="137160" cy="594360"/>
+          </a:xfrm>
+          <a:prstGeom prst="rect">
+            <a:avLst/>
+          </a:prstGeom>
+          <a:solidFill>
+            <a:srgbClr val="E2725B"/>
+          </a:solidFill>
+          <a:ln/>
+        </p:spPr>
+      </p:sp>
+      <p:sp>
+        <p:nvSpPr>
+          <p:cNvPr id="7" name="Text 5"/>
+          <p:cNvSpPr/>
+          <p:nvPr/>
+        </p:nvSpPr>
+        <p:spPr>
+          <a:xfrm>
+            <a:off x="685800" y="1920240"/>
+            <a:ext cx="2194560" cy="228600"/>
+          </a:xfrm>
+          <a:prstGeom prst="rect">
+            <a:avLst/>
+          </a:prstGeom>
+          <a:noFill/>
+          <a:ln/>
+        </p:spPr>
+        <p:txBody>
+          <a:bodyPr wrap="square" rtlCol="0" anchor="ctr"/>
+          <a:lstStyle/>
+          <a:p>
+            <a:pPr indent="0" marL="0">
+              <a:buNone/>
+            </a:pPr>
+            <a:r>
+              <a:rPr lang="en-US" sz="1100" b="1" dirty="0">
+                <a:solidFill>
+                  <a:srgbClr val="1A2238"/>
+                </a:solidFill>
+                <a:latin typeface="Microsoft YaHei" pitchFamily="34" charset="0"/>
+                <a:ea typeface="Microsoft YaHei" pitchFamily="34" charset="-122"/>
+                <a:cs typeface="Microsoft YaHei" pitchFamily="34" charset="-120"/>
+              </a:rPr>
+              <a:t>对抗位 (Confront)</a:t>
+            </a:r>
+            <a:endParaRPr lang="en-US" sz="1100" dirty="0"/>
+          </a:p>
+        </p:txBody>
+      </p:sp>
+      <p:sp>
+        <p:nvSpPr>
+          <p:cNvPr id="8" name="Text 6"/>
+          <p:cNvSpPr/>
+          <p:nvPr/>
+        </p:nvSpPr>
+        <p:spPr>
+          <a:xfrm>
+            <a:off x="685800" y="2167128"/>
+            <a:ext cx="2194560" cy="228600"/>
+          </a:xfrm>
+          <a:prstGeom prst="rect">
+            <a:avLst/>
+          </a:prstGeom>
+          <a:noFill/>
+          <a:ln/>
+        </p:spPr>
+        <p:txBody>
+          <a:bodyPr wrap="square" rtlCol="0" anchor="ctr"/>
+          <a:lstStyle/>
+          <a:p>
+            <a:pPr indent="0" marL="0">
+              <a:buNone/>
+            </a:pPr>
+            <a:r>
+              <a:rPr lang="en-US" sz="900" i="1" dirty="0">
+                <a:solidFill>
+                  <a:srgbClr val="E2725B"/>
+                </a:solidFill>
+                <a:latin typeface="Microsoft YaHei" pitchFamily="34" charset="0"/>
+                <a:ea typeface="Microsoft YaHei" pitchFamily="34" charset="-122"/>
+                <a:cs typeface="Microsoft YaHei" pitchFamily="34" charset="-120"/>
+              </a:rPr>
+              <a:t>1·3·8 号</a:t>
+            </a:r>
+            <a:endParaRPr lang="en-US" sz="900" dirty="0"/>
+          </a:p>
+        </p:txBody>
+      </p:sp>
+      <p:sp>
+        <p:nvSpPr>
+          <p:cNvPr id="9" name="Text 7"/>
+          <p:cNvSpPr/>
+          <p:nvPr/>
+        </p:nvSpPr>
+        <p:spPr>
+          <a:xfrm>
+            <a:off x="2926080" y="1965960"/>
+            <a:ext cx="1554480" cy="411480"/>
+          </a:xfrm>
+          <a:prstGeom prst="rect">
+            <a:avLst/>
+          </a:prstGeom>
+          <a:noFill/>
+          <a:ln/>
+        </p:spPr>
+        <p:txBody>
+          <a:bodyPr wrap="square" rtlCol="0" anchor="ctr"/>
+          <a:lstStyle/>
+          <a:p>
+            <a:pPr indent="0" marL="0">
+              <a:lnSpc>
+                <a:spcPct val="120000"/>
+              </a:lnSpc>
+              <a:buNone/>
+            </a:pPr>
+            <a:r>
+              <a:rPr lang="en-US" sz="900" dirty="0">
+                <a:solidFill>
+                  <a:srgbClr val="4A5568"/>
+                </a:solidFill>
+                <a:latin typeface="Microsoft YaHei" pitchFamily="34" charset="0"/>
+                <a:ea typeface="Microsoft YaHei" pitchFamily="34" charset="-122"/>
+                <a:cs typeface="Microsoft YaHei" pitchFamily="34" charset="-120"/>
+              </a:rPr>
+              <a:t>面对压力: 冲/控制/取得</a:t>
+            </a:r>
+            <a:endParaRPr lang="en-US" sz="900" dirty="0"/>
+          </a:p>
+        </p:txBody>
+      </p:sp>
+      <p:sp>
+        <p:nvSpPr>
+          <p:cNvPr id="10" name="Shape 8"/>
+          <p:cNvSpPr/>
+          <p:nvPr/>
+        </p:nvSpPr>
+        <p:spPr>
+          <a:xfrm>
+            <a:off x="457200" y="2560320"/>
+            <a:ext cx="4114800" cy="594360"/>
+          </a:xfrm>
+          <a:prstGeom prst="rect">
+            <a:avLst/>
+          </a:prstGeom>
+          <a:solidFill>
+            <a:srgbClr val="FFFFFF"/>
+          </a:solidFill>
+          <a:ln w="12700">
+            <a:solidFill>
+              <a:srgbClr val="D4C5B9"/>
+            </a:solidFill>
+            <a:prstDash val="solid"/>
+          </a:ln>
+        </p:spPr>
+      </p:sp>
+      <p:sp>
+        <p:nvSpPr>
+          <p:cNvPr id="11" name="Shape 9"/>
+          <p:cNvSpPr/>
+          <p:nvPr/>
+        </p:nvSpPr>
+        <p:spPr>
+          <a:xfrm>
+            <a:off x="457200" y="2560320"/>
+            <a:ext cx="137160" cy="594360"/>
+          </a:xfrm>
+          <a:prstGeom prst="rect">
+            <a:avLst/>
+          </a:prstGeom>
+          <a:solidFill>
+            <a:srgbClr val="E2725B"/>
+          </a:solidFill>
+          <a:ln/>
+        </p:spPr>
+      </p:sp>
+      <p:sp>
+        <p:nvSpPr>
+          <p:cNvPr id="12" name="Text 10"/>
+          <p:cNvSpPr/>
+          <p:nvPr/>
+        </p:nvSpPr>
+        <p:spPr>
+          <a:xfrm>
+            <a:off x="685800" y="2606040"/>
+            <a:ext cx="2194560" cy="228600"/>
+          </a:xfrm>
+          <a:prstGeom prst="rect">
+            <a:avLst/>
+          </a:prstGeom>
+          <a:noFill/>
+          <a:ln/>
+        </p:spPr>
+        <p:txBody>
+          <a:bodyPr wrap="square" rtlCol="0" anchor="ctr"/>
+          <a:lstStyle/>
+          <a:p>
+            <a:pPr indent="0" marL="0">
+              <a:buNone/>
+            </a:pPr>
+            <a:r>
+              <a:rPr lang="en-US" sz="1100" b="1" dirty="0">
+                <a:solidFill>
+                  <a:srgbClr val="1A2238"/>
+                </a:solidFill>
+                <a:latin typeface="Microsoft YaHei" pitchFamily="34" charset="0"/>
+                <a:ea typeface="Microsoft YaHei" pitchFamily="34" charset="-122"/>
+                <a:cs typeface="Microsoft YaHei" pitchFamily="34" charset="-120"/>
+              </a:rPr>
+              <a:t>退行位 (Retreat)</a:t>
+            </a:r>
+            <a:endParaRPr lang="en-US" sz="1100" dirty="0"/>
+          </a:p>
+        </p:txBody>
+      </p:sp>
+      <p:sp>
+        <p:nvSpPr>
+          <p:cNvPr id="13" name="Text 11"/>
+          <p:cNvSpPr/>
+          <p:nvPr/>
+        </p:nvSpPr>
+        <p:spPr>
+          <a:xfrm>
+            <a:off x="685800" y="2852928"/>
+            <a:ext cx="2194560" cy="228600"/>
+          </a:xfrm>
+          <a:prstGeom prst="rect">
+            <a:avLst/>
+          </a:prstGeom>
+          <a:noFill/>
+          <a:ln/>
+        </p:spPr>
+        <p:txBody>
+          <a:bodyPr wrap="square" rtlCol="0" anchor="ctr"/>
+          <a:lstStyle/>
+          <a:p>
+            <a:pPr indent="0" marL="0">
+              <a:buNone/>
+            </a:pPr>
+            <a:r>
+              <a:rPr lang="en-US" sz="900" i="1" dirty="0">
+                <a:solidFill>
+                  <a:srgbClr val="E2725B"/>
+                </a:solidFill>
+                <a:latin typeface="Microsoft YaHei" pitchFamily="34" charset="0"/>
+                <a:ea typeface="Microsoft YaHei" pitchFamily="34" charset="-122"/>
+                <a:cs typeface="Microsoft YaHei" pitchFamily="34" charset="-120"/>
+              </a:rPr>
+              <a:t>4·5·9 号</a:t>
+            </a:r>
+            <a:endParaRPr lang="en-US" sz="900" dirty="0"/>
+          </a:p>
+        </p:txBody>
+      </p:sp>
+      <p:sp>
+        <p:nvSpPr>
+          <p:cNvPr id="14" name="Text 12"/>
+          <p:cNvSpPr/>
+          <p:nvPr/>
+        </p:nvSpPr>
+        <p:spPr>
+          <a:xfrm>
+            <a:off x="2926080" y="2651760"/>
+            <a:ext cx="1554480" cy="411480"/>
+          </a:xfrm>
+          <a:prstGeom prst="rect">
+            <a:avLst/>
+          </a:prstGeom>
+          <a:noFill/>
+          <a:ln/>
+        </p:spPr>
+        <p:txBody>
+          <a:bodyPr wrap="square" rtlCol="0" anchor="ctr"/>
+          <a:lstStyle/>
+          <a:p>
+            <a:pPr indent="0" marL="0">
+              <a:lnSpc>
+                <a:spcPct val="120000"/>
+              </a:lnSpc>
+              <a:buNone/>
+            </a:pPr>
+            <a:r>
+              <a:rPr lang="en-US" sz="900" dirty="0">
+                <a:solidFill>
+                  <a:srgbClr val="4A5568"/>
+                </a:solidFill>
+                <a:latin typeface="Microsoft YaHei" pitchFamily="34" charset="0"/>
+                <a:ea typeface="Microsoft YaHei" pitchFamily="34" charset="-122"/>
+                <a:cs typeface="Microsoft YaHei" pitchFamily="34" charset="-120"/>
+              </a:rPr>
+              <a:t>面对压力: 退/隔离/溶解</a:t>
+            </a:r>
+            <a:endParaRPr lang="en-US" sz="900" dirty="0"/>
+          </a:p>
+        </p:txBody>
+      </p:sp>
+      <p:sp>
+        <p:nvSpPr>
+          <p:cNvPr id="15" name="Shape 13"/>
+          <p:cNvSpPr/>
+          <p:nvPr/>
+        </p:nvSpPr>
+        <p:spPr>
+          <a:xfrm>
+            <a:off x="457200" y="3246120"/>
+            <a:ext cx="4114800" cy="594360"/>
+          </a:xfrm>
+          <a:prstGeom prst="rect">
+            <a:avLst/>
+          </a:prstGeom>
+          <a:solidFill>
+            <a:srgbClr val="FFFFFF"/>
+          </a:solidFill>
+          <a:ln w="12700">
+            <a:solidFill>
+              <a:srgbClr val="D4C5B9"/>
+            </a:solidFill>
+            <a:prstDash val="solid"/>
+          </a:ln>
+        </p:spPr>
+      </p:sp>
+      <p:sp>
+        <p:nvSpPr>
+          <p:cNvPr id="16" name="Shape 14"/>
+          <p:cNvSpPr/>
+          <p:nvPr/>
+        </p:nvSpPr>
+        <p:spPr>
+          <a:xfrm>
+            <a:off x="457200" y="3246120"/>
+            <a:ext cx="137160" cy="594360"/>
+          </a:xfrm>
+          <a:prstGeom prst="rect">
+            <a:avLst/>
+          </a:prstGeom>
+          <a:solidFill>
+            <a:srgbClr val="E2725B"/>
+          </a:solidFill>
+          <a:ln/>
+        </p:spPr>
+      </p:sp>
+      <p:sp>
+        <p:nvSpPr>
+          <p:cNvPr id="17" name="Text 15"/>
+          <p:cNvSpPr/>
+          <p:nvPr/>
+        </p:nvSpPr>
+        <p:spPr>
+          <a:xfrm>
+            <a:off x="685800" y="3291840"/>
+            <a:ext cx="2194560" cy="228600"/>
+          </a:xfrm>
+          <a:prstGeom prst="rect">
+            <a:avLst/>
+          </a:prstGeom>
+          <a:noFill/>
+          <a:ln/>
+        </p:spPr>
+        <p:txBody>
+          <a:bodyPr wrap="square" rtlCol="0" anchor="ctr"/>
+          <a:lstStyle/>
+          <a:p>
+            <a:pPr indent="0" marL="0">
+              <a:buNone/>
+            </a:pPr>
+            <a:r>
+              <a:rPr lang="en-US" sz="1100" b="1" dirty="0">
+                <a:solidFill>
+                  <a:srgbClr val="1A2238"/>
+                </a:solidFill>
+                <a:latin typeface="Microsoft YaHei" pitchFamily="34" charset="0"/>
+                <a:ea typeface="Microsoft YaHei" pitchFamily="34" charset="-122"/>
+                <a:cs typeface="Microsoft YaHei" pitchFamily="34" charset="-120"/>
+              </a:rPr>
+              <a:t>警觉位 (Regulate)</a:t>
+            </a:r>
+            <a:endParaRPr lang="en-US" sz="1100" dirty="0"/>
+          </a:p>
+        </p:txBody>
+      </p:sp>
+      <p:sp>
+        <p:nvSpPr>
+          <p:cNvPr id="18" name="Text 16"/>
+          <p:cNvSpPr/>
+          <p:nvPr/>
+        </p:nvSpPr>
+        <p:spPr>
+          <a:xfrm>
+            <a:off x="685800" y="3538728"/>
+            <a:ext cx="2194560" cy="228600"/>
+          </a:xfrm>
+          <a:prstGeom prst="rect">
+            <a:avLst/>
+          </a:prstGeom>
+          <a:noFill/>
+          <a:ln/>
+        </p:spPr>
+        <p:txBody>
+          <a:bodyPr wrap="square" rtlCol="0" anchor="ctr"/>
+          <a:lstStyle/>
+          <a:p>
+            <a:pPr indent="0" marL="0">
+              <a:buNone/>
+            </a:pPr>
+            <a:r>
+              <a:rPr lang="en-US" sz="900" i="1" dirty="0">
+                <a:solidFill>
+                  <a:srgbClr val="E2725B"/>
+                </a:solidFill>
+                <a:latin typeface="Microsoft YaHei" pitchFamily="34" charset="0"/>
+                <a:ea typeface="Microsoft YaHei" pitchFamily="34" charset="-122"/>
+                <a:cs typeface="Microsoft YaHei" pitchFamily="34" charset="-120"/>
+              </a:rPr>
+              <a:t>2·6·7 号</a:t>
+            </a:r>
+            <a:endParaRPr lang="en-US" sz="900" dirty="0"/>
+          </a:p>
+        </p:txBody>
+      </p:sp>
+      <p:sp>
+        <p:nvSpPr>
+          <p:cNvPr id="19" name="Text 17"/>
+          <p:cNvSpPr/>
+          <p:nvPr/>
+        </p:nvSpPr>
+        <p:spPr>
+          <a:xfrm>
+            <a:off x="2926080" y="3337560"/>
+            <a:ext cx="1554480" cy="411480"/>
+          </a:xfrm>
+          <a:prstGeom prst="rect">
+            <a:avLst/>
+          </a:prstGeom>
+          <a:noFill/>
+          <a:ln/>
+        </p:spPr>
+        <p:txBody>
+          <a:bodyPr wrap="square" rtlCol="0" anchor="ctr"/>
+          <a:lstStyle/>
+          <a:p>
+            <a:pPr indent="0" marL="0">
+              <a:lnSpc>
+                <a:spcPct val="120000"/>
+              </a:lnSpc>
+              <a:buNone/>
+            </a:pPr>
+            <a:r>
+              <a:rPr lang="en-US" sz="900" dirty="0">
+                <a:solidFill>
+                  <a:srgbClr val="4A5568"/>
+                </a:solidFill>
+                <a:latin typeface="Microsoft YaHei" pitchFamily="34" charset="0"/>
+                <a:ea typeface="Microsoft YaHei" pitchFamily="34" charset="-122"/>
+                <a:cs typeface="Microsoft YaHei" pitchFamily="34" charset="-120"/>
+              </a:rPr>
+              <a:t>面对压力: 调节他人/备份/分散</a:t>
+            </a:r>
+            <a:endParaRPr lang="en-US" sz="900" dirty="0"/>
+          </a:p>
+        </p:txBody>
+      </p:sp>
+      <p:sp>
+        <p:nvSpPr>
+          <p:cNvPr id="20" name="Text 18"/>
+          <p:cNvSpPr/>
+          <p:nvPr/>
+        </p:nvSpPr>
+        <p:spPr>
+          <a:xfrm>
+            <a:off x="4846320" y="1463040"/>
+            <a:ext cx="4114800" cy="320040"/>
+          </a:xfrm>
+          <a:prstGeom prst="rect">
+            <a:avLst/>
+          </a:prstGeom>
+          <a:noFill/>
+          <a:ln/>
+        </p:spPr>
+        <p:txBody>
+          <a:bodyPr wrap="square" rtlCol="0" anchor="ctr"/>
+          <a:lstStyle/>
+          <a:p>
+            <a:pPr indent="0" marL="0">
+              <a:buNone/>
+            </a:pPr>
+            <a:r>
+              <a:rPr lang="en-US" sz="1400" b="1" dirty="0">
+                <a:solidFill>
+                  <a:srgbClr val="E2725B"/>
+                </a:solidFill>
+                <a:latin typeface="Microsoft YaHei" pitchFamily="34" charset="0"/>
+                <a:ea typeface="Microsoft YaHei" pitchFamily="34" charset="-122"/>
+                <a:cs typeface="Microsoft YaHei" pitchFamily="34" charset="-120"/>
+              </a:rPr>
+              <a:t>12 构型 (4 依恋 × 3 防御位)</a:t>
+            </a:r>
+            <a:endParaRPr lang="en-US" sz="1400" dirty="0"/>
+          </a:p>
+        </p:txBody>
+      </p:sp>
+      <p:sp>
+        <p:nvSpPr>
+          <p:cNvPr id="21" name="Shape 19"/>
+          <p:cNvSpPr/>
+          <p:nvPr/>
+        </p:nvSpPr>
+        <p:spPr>
+          <a:xfrm>
+            <a:off x="4846320" y="1874520"/>
+            <a:ext cx="1371600" cy="274320"/>
+          </a:xfrm>
+          <a:prstGeom prst="rect">
+            <a:avLst/>
+          </a:prstGeom>
+          <a:solidFill>
+            <a:srgbClr val="1A2238"/>
+          </a:solidFill>
+          <a:ln/>
+        </p:spPr>
+      </p:sp>
+      <p:sp>
+        <p:nvSpPr>
+          <p:cNvPr id="22" name="Text 20"/>
+          <p:cNvSpPr/>
+          <p:nvPr/>
+        </p:nvSpPr>
+        <p:spPr>
+          <a:xfrm>
+            <a:off x="4846320" y="1892808"/>
+            <a:ext cx="1371600" cy="237744"/>
+          </a:xfrm>
+          <a:prstGeom prst="rect">
+            <a:avLst/>
+          </a:prstGeom>
+          <a:noFill/>
+          <a:ln/>
+        </p:spPr>
+        <p:txBody>
+          <a:bodyPr wrap="square" rtlCol="0" anchor="ctr"/>
+          <a:lstStyle/>
+          <a:p>
+            <a:pPr algn="ctr" indent="0" marL="0">
+              <a:buNone/>
+            </a:pPr>
+            <a:r>
+              <a:rPr lang="en-US" sz="1100" b="1" dirty="0">
+                <a:solidFill>
+                  <a:srgbClr val="FFFFFF"/>
+                </a:solidFill>
+                <a:latin typeface="Microsoft YaHei" pitchFamily="34" charset="0"/>
+                <a:ea typeface="Microsoft YaHei" pitchFamily="34" charset="-122"/>
+                <a:cs typeface="Microsoft YaHei" pitchFamily="34" charset="-120"/>
+              </a:rPr>
+              <a:t>焦虑</a:t>
+            </a:r>
+            <a:endParaRPr lang="en-US" sz="1100" dirty="0"/>
+          </a:p>
+        </p:txBody>
+      </p:sp>
+      <p:sp>
+        <p:nvSpPr>
+          <p:cNvPr id="23" name="Shape 21"/>
+          <p:cNvSpPr/>
+          <p:nvPr/>
+        </p:nvSpPr>
+        <p:spPr>
+          <a:xfrm>
+            <a:off x="4846320" y="1874520"/>
+            <a:ext cx="1371600" cy="274320"/>
+          </a:xfrm>
+          <a:prstGeom prst="rect">
+            <a:avLst/>
+          </a:prstGeom>
+          <a:solidFill>
+            <a:srgbClr val="1A2238"/>
+          </a:solidFill>
+          <a:ln/>
+        </p:spPr>
+      </p:sp>
+      <p:sp>
+        <p:nvSpPr>
+          <p:cNvPr id="24" name="Text 22"/>
+          <p:cNvSpPr/>
+          <p:nvPr/>
+        </p:nvSpPr>
+        <p:spPr>
+          <a:xfrm>
+            <a:off x="6217920" y="1892808"/>
+            <a:ext cx="1371600" cy="237744"/>
+          </a:xfrm>
+          <a:prstGeom prst="rect">
+            <a:avLst/>
+          </a:prstGeom>
+          <a:noFill/>
+          <a:ln/>
+        </p:spPr>
+        <p:txBody>
+          <a:bodyPr wrap="square" rtlCol="0" anchor="ctr"/>
+          <a:lstStyle/>
+          <a:p>
+            <a:pPr algn="ctr" indent="0" marL="0">
+              <a:buNone/>
+            </a:pPr>
+            <a:r>
+              <a:rPr lang="en-US" sz="1100" b="1" dirty="0">
+                <a:solidFill>
+                  <a:srgbClr val="FFFFFF"/>
+                </a:solidFill>
+                <a:latin typeface="Microsoft YaHei" pitchFamily="34" charset="0"/>
+                <a:ea typeface="Microsoft YaHei" pitchFamily="34" charset="-122"/>
+                <a:cs typeface="Microsoft YaHei" pitchFamily="34" charset="-120"/>
+              </a:rPr>
+              <a:t>回避</a:t>
+            </a:r>
+            <a:endParaRPr lang="en-US" sz="1100" dirty="0"/>
+          </a:p>
+        </p:txBody>
+      </p:sp>
+      <p:sp>
+        <p:nvSpPr>
+          <p:cNvPr id="25" name="Shape 23"/>
+          <p:cNvSpPr/>
+          <p:nvPr/>
+        </p:nvSpPr>
+        <p:spPr>
+          <a:xfrm>
+            <a:off x="4846320" y="1874520"/>
+            <a:ext cx="1371600" cy="274320"/>
+          </a:xfrm>
+          <a:prstGeom prst="rect">
+            <a:avLst/>
+          </a:prstGeom>
+          <a:solidFill>
+            <a:srgbClr val="1A2238"/>
+          </a:solidFill>
+          <a:ln/>
+        </p:spPr>
+      </p:sp>
+      <p:sp>
+        <p:nvSpPr>
+          <p:cNvPr id="26" name="Text 24"/>
+          <p:cNvSpPr/>
+          <p:nvPr/>
+        </p:nvSpPr>
+        <p:spPr>
+          <a:xfrm>
+            <a:off x="7589520" y="1892808"/>
+            <a:ext cx="1371600" cy="237744"/>
+          </a:xfrm>
+          <a:prstGeom prst="rect">
+            <a:avLst/>
+          </a:prstGeom>
+          <a:noFill/>
+          <a:ln/>
+        </p:spPr>
+        <p:txBody>
+          <a:bodyPr wrap="square" rtlCol="0" anchor="ctr"/>
+          <a:lstStyle/>
+          <a:p>
+            <a:pPr algn="ctr" indent="0" marL="0">
+              <a:buNone/>
+            </a:pPr>
+            <a:r>
+              <a:rPr lang="en-US" sz="1100" b="1" dirty="0">
+                <a:solidFill>
+                  <a:srgbClr val="FFFFFF"/>
+                </a:solidFill>
+                <a:latin typeface="Microsoft YaHei" pitchFamily="34" charset="0"/>
+                <a:ea typeface="Microsoft YaHei" pitchFamily="34" charset="-122"/>
+                <a:cs typeface="Microsoft YaHei" pitchFamily="34" charset="-120"/>
+              </a:rPr>
+              <a:t>混乱</a:t>
+            </a:r>
+            <a:endParaRPr lang="en-US" sz="1100" dirty="0"/>
+          </a:p>
+        </p:txBody>
+      </p:sp>
+      <p:sp>
+        <p:nvSpPr>
+          <p:cNvPr id="27" name="Shape 25"/>
+          <p:cNvSpPr/>
+          <p:nvPr/>
+        </p:nvSpPr>
+        <p:spPr>
+          <a:xfrm>
+            <a:off x="4846320" y="1874520"/>
+            <a:ext cx="1371600" cy="274320"/>
+          </a:xfrm>
+          <a:prstGeom prst="rect">
+            <a:avLst/>
+          </a:prstGeom>
+          <a:solidFill>
+            <a:srgbClr val="1A2238"/>
+          </a:solidFill>
+          <a:ln/>
+        </p:spPr>
+      </p:sp>
+      <p:sp>
+        <p:nvSpPr>
+          <p:cNvPr id="28" name="Text 26"/>
+          <p:cNvSpPr/>
+          <p:nvPr/>
+        </p:nvSpPr>
+        <p:spPr>
+          <a:xfrm>
+            <a:off x="8961120" y="1892808"/>
+            <a:ext cx="1371600" cy="237744"/>
+          </a:xfrm>
+          <a:prstGeom prst="rect">
+            <a:avLst/>
+          </a:prstGeom>
+          <a:noFill/>
+          <a:ln/>
+        </p:spPr>
+        <p:txBody>
+          <a:bodyPr wrap="square" rtlCol="0" anchor="ctr"/>
+          <a:lstStyle/>
+          <a:p>
+            <a:pPr algn="ctr" indent="0" marL="0">
+              <a:buNone/>
+            </a:pPr>
+            <a:r>
+              <a:rPr lang="en-US" sz="1100" b="1" dirty="0">
+                <a:solidFill>
+                  <a:srgbClr val="FFFFFF"/>
+                </a:solidFill>
+                <a:latin typeface="Microsoft YaHei" pitchFamily="34" charset="0"/>
+                <a:ea typeface="Microsoft YaHei" pitchFamily="34" charset="-122"/>
+                <a:cs typeface="Microsoft YaHei" pitchFamily="34" charset="-120"/>
+              </a:rPr>
+              <a:t>安全</a:t>
+            </a:r>
+            <a:endParaRPr lang="en-US" sz="1100" dirty="0"/>
+          </a:p>
+        </p:txBody>
+      </p:sp>
+      <p:sp>
+        <p:nvSpPr>
+          <p:cNvPr id="29" name="Shape 27"/>
+          <p:cNvSpPr/>
+          <p:nvPr/>
+        </p:nvSpPr>
+        <p:spPr>
+          <a:xfrm>
+            <a:off x="4846320" y="2148840"/>
+            <a:ext cx="822960" cy="457200"/>
+          </a:xfrm>
+          <a:prstGeom prst="rect">
+            <a:avLst/>
+          </a:prstGeom>
+          <a:solidFill>
+            <a:srgbClr val="D4C5B9"/>
+          </a:solidFill>
+          <a:ln/>
+        </p:spPr>
+      </p:sp>
+      <p:sp>
+        <p:nvSpPr>
+          <p:cNvPr id="30" name="Text 28"/>
+          <p:cNvSpPr/>
+          <p:nvPr/>
+        </p:nvSpPr>
+        <p:spPr>
+          <a:xfrm>
+            <a:off x="4846320" y="2240280"/>
+            <a:ext cx="822960" cy="274320"/>
+          </a:xfrm>
+          <a:prstGeom prst="rect">
+            <a:avLst/>
+          </a:prstGeom>
+          <a:noFill/>
+          <a:ln/>
+        </p:spPr>
+        <p:txBody>
+          <a:bodyPr wrap="square" rtlCol="0" anchor="ctr"/>
+          <a:lstStyle/>
+          <a:p>
+            <a:pPr algn="ctr" indent="0" marL="0">
+              <a:buNone/>
+            </a:pPr>
+            <a:r>
+              <a:rPr lang="en-US" sz="1000" b="1" dirty="0">
+                <a:solidFill>
+                  <a:srgbClr val="1A2238"/>
+                </a:solidFill>
+                <a:latin typeface="Microsoft YaHei" pitchFamily="34" charset="0"/>
+                <a:ea typeface="Microsoft YaHei" pitchFamily="34" charset="-122"/>
+                <a:cs typeface="Microsoft YaHei" pitchFamily="34" charset="-120"/>
+              </a:rPr>
+              <a:t>警觉</a:t>
+            </a:r>
+            <a:endParaRPr lang="en-US" sz="1000" dirty="0"/>
+          </a:p>
+        </p:txBody>
+      </p:sp>
+      <p:sp>
+        <p:nvSpPr>
+          <p:cNvPr id="31" name="Shape 29"/>
+          <p:cNvSpPr/>
+          <p:nvPr/>
+        </p:nvSpPr>
+        <p:spPr>
+          <a:xfrm>
+            <a:off x="5669280" y="2148840"/>
+            <a:ext cx="1165860" cy="457200"/>
+          </a:xfrm>
+          <a:prstGeom prst="rect">
+            <a:avLst/>
+          </a:prstGeom>
+          <a:solidFill>
+            <a:srgbClr val="FFFFFF"/>
+          </a:solidFill>
+          <a:ln w="6350">
+            <a:solidFill>
+              <a:srgbClr val="D4C5B9"/>
+            </a:solidFill>
+            <a:prstDash val="solid"/>
+          </a:ln>
+        </p:spPr>
+      </p:sp>
+      <p:sp>
+        <p:nvSpPr>
+          <p:cNvPr id="32" name="Text 30"/>
+          <p:cNvSpPr/>
+          <p:nvPr/>
+        </p:nvSpPr>
+        <p:spPr>
+          <a:xfrm>
+            <a:off x="5669280" y="2267712"/>
+            <a:ext cx="1165860" cy="228600"/>
+          </a:xfrm>
+          <a:prstGeom prst="rect">
+            <a:avLst/>
+          </a:prstGeom>
+          <a:noFill/>
+          <a:ln/>
+        </p:spPr>
+        <p:txBody>
+          <a:bodyPr wrap="square" rtlCol="0" anchor="ctr"/>
+          <a:lstStyle/>
+          <a:p>
+            <a:pPr algn="ctr" indent="0" marL="0">
+              <a:buNone/>
+            </a:pPr>
+            <a:r>
+              <a:rPr lang="en-US" sz="900" dirty="0">
+                <a:solidFill>
+                  <a:srgbClr val="4A5568"/>
+                </a:solidFill>
+                <a:latin typeface="Microsoft YaHei" pitchFamily="34" charset="0"/>
+                <a:ea typeface="Microsoft YaHei" pitchFamily="34" charset="-122"/>
+                <a:cs typeface="Microsoft YaHei" pitchFamily="34" charset="-120"/>
+              </a:rPr>
+              <a:t>× 2 号</a:t>
+            </a:r>
+            <a:endParaRPr lang="en-US" sz="900" dirty="0"/>
+          </a:p>
+        </p:txBody>
+      </p:sp>
+      <p:sp>
+        <p:nvSpPr>
+          <p:cNvPr id="33" name="Shape 31"/>
+          <p:cNvSpPr/>
+          <p:nvPr/>
+        </p:nvSpPr>
+        <p:spPr>
+          <a:xfrm>
+            <a:off x="6835140" y="2148840"/>
+            <a:ext cx="1165860" cy="457200"/>
+          </a:xfrm>
+          <a:prstGeom prst="rect">
+            <a:avLst/>
+          </a:prstGeom>
+          <a:solidFill>
+            <a:srgbClr val="FFFFFF"/>
+          </a:solidFill>
+          <a:ln w="6350">
+            <a:solidFill>
+              <a:srgbClr val="D4C5B9"/>
+            </a:solidFill>
+            <a:prstDash val="solid"/>
+          </a:ln>
+        </p:spPr>
+      </p:sp>
+      <p:sp>
+        <p:nvSpPr>
+          <p:cNvPr id="34" name="Text 32"/>
+          <p:cNvSpPr/>
+          <p:nvPr/>
+        </p:nvSpPr>
+        <p:spPr>
+          <a:xfrm>
+            <a:off x="6835140" y="2267712"/>
+            <a:ext cx="1165860" cy="228600"/>
+          </a:xfrm>
+          <a:prstGeom prst="rect">
+            <a:avLst/>
+          </a:prstGeom>
+          <a:noFill/>
+          <a:ln/>
+        </p:spPr>
+        <p:txBody>
+          <a:bodyPr wrap="square" rtlCol="0" anchor="ctr"/>
+          <a:lstStyle/>
+          <a:p>
+            <a:pPr algn="ctr" indent="0" marL="0">
+              <a:buNone/>
+            </a:pPr>
+            <a:r>
+              <a:rPr lang="en-US" sz="900" dirty="0">
+                <a:solidFill>
+                  <a:srgbClr val="4A5568"/>
+                </a:solidFill>
+                <a:latin typeface="Microsoft YaHei" pitchFamily="34" charset="0"/>
+                <a:ea typeface="Microsoft YaHei" pitchFamily="34" charset="-122"/>
+                <a:cs typeface="Microsoft YaHei" pitchFamily="34" charset="-120"/>
+              </a:rPr>
+              <a:t>× 6 号</a:t>
+            </a:r>
+            <a:endParaRPr lang="en-US" sz="900" dirty="0"/>
+          </a:p>
+        </p:txBody>
+      </p:sp>
+      <p:sp>
+        <p:nvSpPr>
+          <p:cNvPr id="35" name="Shape 33"/>
+          <p:cNvSpPr/>
+          <p:nvPr/>
+        </p:nvSpPr>
+        <p:spPr>
+          <a:xfrm>
+            <a:off x="8001000" y="2148840"/>
+            <a:ext cx="1165860" cy="457200"/>
+          </a:xfrm>
+          <a:prstGeom prst="rect">
+            <a:avLst/>
+          </a:prstGeom>
+          <a:solidFill>
+            <a:srgbClr val="FFFFFF"/>
+          </a:solidFill>
+          <a:ln w="6350">
+            <a:solidFill>
+              <a:srgbClr val="D4C5B9"/>
+            </a:solidFill>
+            <a:prstDash val="solid"/>
+          </a:ln>
+        </p:spPr>
+      </p:sp>
+      <p:sp>
+        <p:nvSpPr>
+          <p:cNvPr id="36" name="Text 34"/>
+          <p:cNvSpPr/>
+          <p:nvPr/>
+        </p:nvSpPr>
+        <p:spPr>
+          <a:xfrm>
+            <a:off x="8001000" y="2267712"/>
+            <a:ext cx="1165860" cy="228600"/>
+          </a:xfrm>
+          <a:prstGeom prst="rect">
+            <a:avLst/>
+          </a:prstGeom>
+          <a:noFill/>
+          <a:ln/>
+        </p:spPr>
+        <p:txBody>
+          <a:bodyPr wrap="square" rtlCol="0" anchor="ctr"/>
+          <a:lstStyle/>
+          <a:p>
+            <a:pPr algn="ctr" indent="0" marL="0">
+              <a:buNone/>
+            </a:pPr>
+            <a:r>
+              <a:rPr lang="en-US" sz="900" dirty="0">
+                <a:solidFill>
+                  <a:srgbClr val="4A5568"/>
+                </a:solidFill>
+                <a:latin typeface="Microsoft YaHei" pitchFamily="34" charset="0"/>
+                <a:ea typeface="Microsoft YaHei" pitchFamily="34" charset="-122"/>
+                <a:cs typeface="Microsoft YaHei" pitchFamily="34" charset="-120"/>
+              </a:rPr>
+              <a:t>× 4 号</a:t>
+            </a:r>
+            <a:endParaRPr lang="en-US" sz="900" dirty="0"/>
+          </a:p>
+        </p:txBody>
+      </p:sp>
+      <p:sp>
+        <p:nvSpPr>
+          <p:cNvPr id="37" name="Shape 35"/>
+          <p:cNvSpPr/>
+          <p:nvPr/>
+        </p:nvSpPr>
+        <p:spPr>
+          <a:xfrm>
+            <a:off x="4846320" y="2606040"/>
+            <a:ext cx="822960" cy="457200"/>
+          </a:xfrm>
+          <a:prstGeom prst="rect">
+            <a:avLst/>
+          </a:prstGeom>
+          <a:solidFill>
+            <a:srgbClr val="D4C5B9"/>
+          </a:solidFill>
+          <a:ln/>
+        </p:spPr>
+      </p:sp>
+      <p:sp>
+        <p:nvSpPr>
+          <p:cNvPr id="38" name="Text 36"/>
+          <p:cNvSpPr/>
+          <p:nvPr/>
+        </p:nvSpPr>
+        <p:spPr>
+          <a:xfrm>
+            <a:off x="4846320" y="2697480"/>
+            <a:ext cx="822960" cy="274320"/>
+          </a:xfrm>
+          <a:prstGeom prst="rect">
+            <a:avLst/>
+          </a:prstGeom>
+          <a:noFill/>
+          <a:ln/>
+        </p:spPr>
+        <p:txBody>
+          <a:bodyPr wrap="square" rtlCol="0" anchor="ctr"/>
+          <a:lstStyle/>
+          <a:p>
+            <a:pPr algn="ctr" indent="0" marL="0">
+              <a:buNone/>
+            </a:pPr>
+            <a:r>
+              <a:rPr lang="en-US" sz="1000" b="1" dirty="0">
+                <a:solidFill>
+                  <a:srgbClr val="1A2238"/>
+                </a:solidFill>
+                <a:latin typeface="Microsoft YaHei" pitchFamily="34" charset="0"/>
+                <a:ea typeface="Microsoft YaHei" pitchFamily="34" charset="-122"/>
+                <a:cs typeface="Microsoft YaHei" pitchFamily="34" charset="-120"/>
+              </a:rPr>
+              <a:t>对抗</a:t>
+            </a:r>
+            <a:endParaRPr lang="en-US" sz="1000" dirty="0"/>
+          </a:p>
+        </p:txBody>
+      </p:sp>
+      <p:sp>
+        <p:nvSpPr>
+          <p:cNvPr id="39" name="Shape 37"/>
+          <p:cNvSpPr/>
+          <p:nvPr/>
+        </p:nvSpPr>
+        <p:spPr>
+          <a:xfrm>
+            <a:off x="5669280" y="2606040"/>
+            <a:ext cx="1165860" cy="457200"/>
+          </a:xfrm>
+          <a:prstGeom prst="rect">
+            <a:avLst/>
+          </a:prstGeom>
+          <a:solidFill>
+            <a:srgbClr val="FFFFFF"/>
+          </a:solidFill>
+          <a:ln w="6350">
+            <a:solidFill>
+              <a:srgbClr val="D4C5B9"/>
+            </a:solidFill>
+            <a:prstDash val="solid"/>
+          </a:ln>
+        </p:spPr>
+      </p:sp>
+      <p:sp>
+        <p:nvSpPr>
+          <p:cNvPr id="40" name="Text 38"/>
+          <p:cNvSpPr/>
+          <p:nvPr/>
+        </p:nvSpPr>
+        <p:spPr>
+          <a:xfrm>
+            <a:off x="5669280" y="2724912"/>
+            <a:ext cx="1165860" cy="228600"/>
+          </a:xfrm>
+          <a:prstGeom prst="rect">
+            <a:avLst/>
+          </a:prstGeom>
+          <a:noFill/>
+          <a:ln/>
+        </p:spPr>
+        <p:txBody>
+          <a:bodyPr wrap="square" rtlCol="0" anchor="ctr"/>
+          <a:lstStyle/>
+          <a:p>
+            <a:pPr algn="ctr" indent="0" marL="0">
+              <a:buNone/>
+            </a:pPr>
+            <a:r>
+              <a:rPr lang="en-US" sz="900" dirty="0">
+                <a:solidFill>
+                  <a:srgbClr val="4A5568"/>
+                </a:solidFill>
+                <a:latin typeface="Microsoft YaHei" pitchFamily="34" charset="0"/>
+                <a:ea typeface="Microsoft YaHei" pitchFamily="34" charset="-122"/>
+                <a:cs typeface="Microsoft YaHei" pitchFamily="34" charset="-120"/>
+              </a:rPr>
+              <a:t>× 5 号</a:t>
+            </a:r>
+            <a:endParaRPr lang="en-US" sz="900" dirty="0"/>
+          </a:p>
+        </p:txBody>
+      </p:sp>
+      <p:sp>
+        <p:nvSpPr>
+          <p:cNvPr id="41" name="Shape 39"/>
+          <p:cNvSpPr/>
+          <p:nvPr/>
+        </p:nvSpPr>
+        <p:spPr>
+          <a:xfrm>
+            <a:off x="6835140" y="2606040"/>
+            <a:ext cx="1165860" cy="457200"/>
+          </a:xfrm>
+          <a:prstGeom prst="rect">
+            <a:avLst/>
+          </a:prstGeom>
+          <a:solidFill>
+            <a:srgbClr val="FFFFFF"/>
+          </a:solidFill>
+          <a:ln w="6350">
+            <a:solidFill>
+              <a:srgbClr val="D4C5B9"/>
+            </a:solidFill>
+            <a:prstDash val="solid"/>
+          </a:ln>
+        </p:spPr>
+      </p:sp>
+      <p:sp>
+        <p:nvSpPr>
+          <p:cNvPr id="42" name="Text 40"/>
+          <p:cNvSpPr/>
+          <p:nvPr/>
+        </p:nvSpPr>
+        <p:spPr>
+          <a:xfrm>
+            <a:off x="6835140" y="2724912"/>
+            <a:ext cx="1165860" cy="228600"/>
+          </a:xfrm>
+          <a:prstGeom prst="rect">
+            <a:avLst/>
+          </a:prstGeom>
+          <a:noFill/>
+          <a:ln/>
+        </p:spPr>
+        <p:txBody>
+          <a:bodyPr wrap="square" rtlCol="0" anchor="ctr"/>
+          <a:lstStyle/>
+          <a:p>
+            <a:pPr algn="ctr" indent="0" marL="0">
+              <a:buNone/>
+            </a:pPr>
+            <a:r>
+              <a:rPr lang="en-US" sz="900" dirty="0">
+                <a:solidFill>
+                  <a:srgbClr val="4A5568"/>
+                </a:solidFill>
+                <a:latin typeface="Microsoft YaHei" pitchFamily="34" charset="0"/>
+                <a:ea typeface="Microsoft YaHei" pitchFamily="34" charset="-122"/>
+                <a:cs typeface="Microsoft YaHei" pitchFamily="34" charset="-120"/>
+              </a:rPr>
+              <a:t>× 8 号</a:t>
+            </a:r>
+            <a:endParaRPr lang="en-US" sz="900" dirty="0"/>
+          </a:p>
+        </p:txBody>
+      </p:sp>
+      <p:sp>
+        <p:nvSpPr>
+          <p:cNvPr id="43" name="Shape 41"/>
+          <p:cNvSpPr/>
+          <p:nvPr/>
+        </p:nvSpPr>
+        <p:spPr>
+          <a:xfrm>
+            <a:off x="8001000" y="2606040"/>
+            <a:ext cx="1165860" cy="457200"/>
+          </a:xfrm>
+          <a:prstGeom prst="rect">
+            <a:avLst/>
+          </a:prstGeom>
+          <a:solidFill>
+            <a:srgbClr val="FFFFFF"/>
+          </a:solidFill>
+          <a:ln w="6350">
+            <a:solidFill>
+              <a:srgbClr val="D4C5B9"/>
+            </a:solidFill>
+            <a:prstDash val="solid"/>
+          </a:ln>
+        </p:spPr>
+      </p:sp>
+      <p:sp>
+        <p:nvSpPr>
+          <p:cNvPr id="44" name="Text 42"/>
+          <p:cNvSpPr/>
+          <p:nvPr/>
+        </p:nvSpPr>
+        <p:spPr>
+          <a:xfrm>
+            <a:off x="8001000" y="2724912"/>
+            <a:ext cx="1165860" cy="228600"/>
+          </a:xfrm>
+          <a:prstGeom prst="rect">
+            <a:avLst/>
+          </a:prstGeom>
+          <a:noFill/>
+          <a:ln/>
+        </p:spPr>
+        <p:txBody>
+          <a:bodyPr wrap="square" rtlCol="0" anchor="ctr"/>
+          <a:lstStyle/>
+          <a:p>
+            <a:pPr algn="ctr" indent="0" marL="0">
+              <a:buNone/>
+            </a:pPr>
+            <a:r>
+              <a:rPr lang="en-US" sz="900" dirty="0">
+                <a:solidFill>
+                  <a:srgbClr val="4A5568"/>
+                </a:solidFill>
+                <a:latin typeface="Microsoft YaHei" pitchFamily="34" charset="0"/>
+                <a:ea typeface="Microsoft YaHei" pitchFamily="34" charset="-122"/>
+                <a:cs typeface="Microsoft YaHei" pitchFamily="34" charset="-120"/>
+              </a:rPr>
+              <a:t>× 3 号</a:t>
+            </a:r>
+            <a:endParaRPr lang="en-US" sz="900" dirty="0"/>
+          </a:p>
+        </p:txBody>
+      </p:sp>
+      <p:sp>
+        <p:nvSpPr>
+          <p:cNvPr id="45" name="Shape 43"/>
+          <p:cNvSpPr/>
+          <p:nvPr/>
+        </p:nvSpPr>
+        <p:spPr>
+          <a:xfrm>
+            <a:off x="4846320" y="3063240"/>
+            <a:ext cx="822960" cy="457200"/>
+          </a:xfrm>
+          <a:prstGeom prst="rect">
+            <a:avLst/>
+          </a:prstGeom>
+          <a:solidFill>
+            <a:srgbClr val="D4C5B9"/>
+          </a:solidFill>
+          <a:ln/>
+        </p:spPr>
+      </p:sp>
+      <p:sp>
+        <p:nvSpPr>
+          <p:cNvPr id="46" name="Text 44"/>
+          <p:cNvSpPr/>
+          <p:nvPr/>
+        </p:nvSpPr>
+        <p:spPr>
+          <a:xfrm>
+            <a:off x="4846320" y="3154680"/>
+            <a:ext cx="822960" cy="274320"/>
+          </a:xfrm>
+          <a:prstGeom prst="rect">
+            <a:avLst/>
+          </a:prstGeom>
+          <a:noFill/>
+          <a:ln/>
+        </p:spPr>
+        <p:txBody>
+          <a:bodyPr wrap="square" rtlCol="0" anchor="ctr"/>
+          <a:lstStyle/>
+          <a:p>
+            <a:pPr algn="ctr" indent="0" marL="0">
+              <a:buNone/>
+            </a:pPr>
+            <a:r>
+              <a:rPr lang="en-US" sz="1000" b="1" dirty="0">
+                <a:solidFill>
+                  <a:srgbClr val="1A2238"/>
+                </a:solidFill>
+                <a:latin typeface="Microsoft YaHei" pitchFamily="34" charset="0"/>
+                <a:ea typeface="Microsoft YaHei" pitchFamily="34" charset="-122"/>
+                <a:cs typeface="Microsoft YaHei" pitchFamily="34" charset="-120"/>
+              </a:rPr>
+              <a:t>退行</a:t>
+            </a:r>
+            <a:endParaRPr lang="en-US" sz="1000" dirty="0"/>
+          </a:p>
+        </p:txBody>
+      </p:sp>
+      <p:sp>
+        <p:nvSpPr>
+          <p:cNvPr id="47" name="Shape 45"/>
+          <p:cNvSpPr/>
+          <p:nvPr/>
+        </p:nvSpPr>
+        <p:spPr>
+          <a:xfrm>
+            <a:off x="5669280" y="3063240"/>
+            <a:ext cx="1165860" cy="457200"/>
+          </a:xfrm>
+          <a:prstGeom prst="rect">
+            <a:avLst/>
+          </a:prstGeom>
+          <a:solidFill>
+            <a:srgbClr val="FFFFFF"/>
+          </a:solidFill>
+          <a:ln w="6350">
+            <a:solidFill>
+              <a:srgbClr val="D4C5B9"/>
+            </a:solidFill>
+            <a:prstDash val="solid"/>
+          </a:ln>
+        </p:spPr>
+      </p:sp>
+      <p:sp>
+        <p:nvSpPr>
+          <p:cNvPr id="48" name="Text 46"/>
+          <p:cNvSpPr/>
+          <p:nvPr/>
+        </p:nvSpPr>
+        <p:spPr>
+          <a:xfrm>
+            <a:off x="5669280" y="3182112"/>
+            <a:ext cx="1165860" cy="228600"/>
+          </a:xfrm>
+          <a:prstGeom prst="rect">
+            <a:avLst/>
+          </a:prstGeom>
+          <a:noFill/>
+          <a:ln/>
+        </p:spPr>
+        <p:txBody>
+          <a:bodyPr wrap="square" rtlCol="0" anchor="ctr"/>
+          <a:lstStyle/>
+          <a:p>
+            <a:pPr algn="ctr" indent="0" marL="0">
+              <a:buNone/>
+            </a:pPr>
+            <a:r>
+              <a:rPr lang="en-US" sz="900" dirty="0">
+                <a:solidFill>
+                  <a:srgbClr val="4A5568"/>
+                </a:solidFill>
+                <a:latin typeface="Microsoft YaHei" pitchFamily="34" charset="0"/>
+                <a:ea typeface="Microsoft YaHei" pitchFamily="34" charset="-122"/>
+                <a:cs typeface="Microsoft YaHei" pitchFamily="34" charset="-120"/>
+              </a:rPr>
+              <a:t>× 4 号</a:t>
+            </a:r>
+            <a:endParaRPr lang="en-US" sz="900" dirty="0"/>
+          </a:p>
+        </p:txBody>
+      </p:sp>
+      <p:sp>
+        <p:nvSpPr>
+          <p:cNvPr id="49" name="Shape 47"/>
+          <p:cNvSpPr/>
+          <p:nvPr/>
+        </p:nvSpPr>
+        <p:spPr>
+          <a:xfrm>
+            <a:off x="6835140" y="3063240"/>
+            <a:ext cx="1165860" cy="457200"/>
+          </a:xfrm>
+          <a:prstGeom prst="rect">
+            <a:avLst/>
+          </a:prstGeom>
+          <a:solidFill>
+            <a:srgbClr val="FFFFFF"/>
+          </a:solidFill>
+          <a:ln w="6350">
+            <a:solidFill>
+              <a:srgbClr val="D4C5B9"/>
+            </a:solidFill>
+            <a:prstDash val="solid"/>
+          </a:ln>
+        </p:spPr>
+      </p:sp>
+      <p:sp>
+        <p:nvSpPr>
+          <p:cNvPr id="50" name="Text 48"/>
+          <p:cNvSpPr/>
+          <p:nvPr/>
+        </p:nvSpPr>
+        <p:spPr>
+          <a:xfrm>
+            <a:off x="6835140" y="3182112"/>
+            <a:ext cx="1165860" cy="228600"/>
+          </a:xfrm>
+          <a:prstGeom prst="rect">
+            <a:avLst/>
+          </a:prstGeom>
+          <a:noFill/>
+          <a:ln/>
+        </p:spPr>
+        <p:txBody>
+          <a:bodyPr wrap="square" rtlCol="0" anchor="ctr"/>
+          <a:lstStyle/>
+          <a:p>
+            <a:pPr algn="ctr" indent="0" marL="0">
+              <a:buNone/>
+            </a:pPr>
+            <a:r>
+              <a:rPr lang="en-US" sz="900" dirty="0">
+                <a:solidFill>
+                  <a:srgbClr val="4A5568"/>
+                </a:solidFill>
+                <a:latin typeface="Microsoft YaHei" pitchFamily="34" charset="0"/>
+                <a:ea typeface="Microsoft YaHei" pitchFamily="34" charset="-122"/>
+                <a:cs typeface="Microsoft YaHei" pitchFamily="34" charset="-120"/>
+              </a:rPr>
+              <a:t>× 1 号</a:t>
+            </a:r>
+            <a:endParaRPr lang="en-US" sz="900" dirty="0"/>
+          </a:p>
+        </p:txBody>
+      </p:sp>
+      <p:sp>
+        <p:nvSpPr>
+          <p:cNvPr id="51" name="Shape 49"/>
+          <p:cNvSpPr/>
+          <p:nvPr/>
+        </p:nvSpPr>
+        <p:spPr>
+          <a:xfrm>
+            <a:off x="8001000" y="3063240"/>
+            <a:ext cx="1165860" cy="457200"/>
+          </a:xfrm>
+          <a:prstGeom prst="rect">
+            <a:avLst/>
+          </a:prstGeom>
+          <a:solidFill>
+            <a:srgbClr val="FFFFFF"/>
+          </a:solidFill>
+          <a:ln w="6350">
+            <a:solidFill>
+              <a:srgbClr val="D4C5B9"/>
+            </a:solidFill>
+            <a:prstDash val="solid"/>
+          </a:ln>
+        </p:spPr>
+      </p:sp>
+      <p:sp>
+        <p:nvSpPr>
+          <p:cNvPr id="52" name="Text 50"/>
+          <p:cNvSpPr/>
+          <p:nvPr/>
+        </p:nvSpPr>
+        <p:spPr>
+          <a:xfrm>
+            <a:off x="8001000" y="3182112"/>
+            <a:ext cx="1165860" cy="228600"/>
+          </a:xfrm>
+          <a:prstGeom prst="rect">
+            <a:avLst/>
+          </a:prstGeom>
+          <a:noFill/>
+          <a:ln/>
+        </p:spPr>
+        <p:txBody>
+          <a:bodyPr wrap="square" rtlCol="0" anchor="ctr"/>
+          <a:lstStyle/>
+          <a:p>
+            <a:pPr algn="ctr" indent="0" marL="0">
+              <a:buNone/>
+            </a:pPr>
+            <a:r>
+              <a:rPr lang="en-US" sz="900" dirty="0">
+                <a:solidFill>
+                  <a:srgbClr val="4A5568"/>
+                </a:solidFill>
+                <a:latin typeface="Microsoft YaHei" pitchFamily="34" charset="0"/>
+                <a:ea typeface="Microsoft YaHei" pitchFamily="34" charset="-122"/>
+                <a:cs typeface="Microsoft YaHei" pitchFamily="34" charset="-120"/>
+              </a:rPr>
+              <a:t>× 9 号</a:t>
+            </a:r>
+            <a:endParaRPr lang="en-US" sz="900" dirty="0"/>
+          </a:p>
+        </p:txBody>
+      </p:sp>
+      <p:sp>
+        <p:nvSpPr>
+          <p:cNvPr id="53" name="Shape 51"/>
+          <p:cNvSpPr/>
+          <p:nvPr/>
+        </p:nvSpPr>
+        <p:spPr>
+          <a:xfrm>
+            <a:off x="4846320" y="3520440"/>
+            <a:ext cx="822960" cy="457200"/>
+          </a:xfrm>
+          <a:prstGeom prst="rect">
+            <a:avLst/>
+          </a:prstGeom>
+          <a:solidFill>
+            <a:srgbClr val="D4C5B9"/>
+          </a:solidFill>
+          <a:ln/>
+        </p:spPr>
+      </p:sp>
+      <p:sp>
+        <p:nvSpPr>
+          <p:cNvPr id="54" name="Text 52"/>
+          <p:cNvSpPr/>
+          <p:nvPr/>
+        </p:nvSpPr>
+        <p:spPr>
+          <a:xfrm>
+            <a:off x="4846320" y="3611880"/>
+            <a:ext cx="822960" cy="274320"/>
+          </a:xfrm>
+          <a:prstGeom prst="rect">
+            <a:avLst/>
+          </a:prstGeom>
+          <a:noFill/>
+          <a:ln/>
+        </p:spPr>
+        <p:txBody>
+          <a:bodyPr wrap="square" rtlCol="0" anchor="ctr"/>
+          <a:lstStyle/>
+          <a:p>
+            <a:pPr algn="ctr" indent="0" marL="0">
+              <a:buNone/>
+            </a:pPr>
+            <a:endParaRPr lang="en-US" sz="1000" dirty="0"/>
+          </a:p>
+        </p:txBody>
+      </p:sp>
+      <p:sp>
+        <p:nvSpPr>
+          <p:cNvPr id="55" name="Shape 53"/>
+          <p:cNvSpPr/>
+          <p:nvPr/>
+        </p:nvSpPr>
+        <p:spPr>
+          <a:xfrm>
+            <a:off x="5669280" y="3520440"/>
+            <a:ext cx="1165860" cy="457200"/>
+          </a:xfrm>
+          <a:prstGeom prst="rect">
+            <a:avLst/>
+          </a:prstGeom>
+          <a:solidFill>
+            <a:srgbClr val="FFFFFF"/>
+          </a:solidFill>
+          <a:ln w="6350">
+            <a:solidFill>
+              <a:srgbClr val="D4C5B9"/>
+            </a:solidFill>
+            <a:prstDash val="solid"/>
+          </a:ln>
+        </p:spPr>
+      </p:sp>
+      <p:sp>
+        <p:nvSpPr>
+          <p:cNvPr id="56" name="Text 54"/>
+          <p:cNvSpPr/>
+          <p:nvPr/>
+        </p:nvSpPr>
+        <p:spPr>
+          <a:xfrm>
+            <a:off x="5669280" y="3639312"/>
+            <a:ext cx="1165860" cy="228600"/>
+          </a:xfrm>
+          <a:prstGeom prst="rect">
+            <a:avLst/>
+          </a:prstGeom>
+          <a:noFill/>
+          <a:ln/>
+        </p:spPr>
+        <p:txBody>
+          <a:bodyPr wrap="square" rtlCol="0" anchor="ctr"/>
+          <a:lstStyle/>
+          <a:p>
+            <a:pPr algn="ctr" indent="0" marL="0">
+              <a:buNone/>
+            </a:pPr>
+            <a:r>
+              <a:rPr lang="en-US" sz="900" dirty="0">
+                <a:solidFill>
+                  <a:srgbClr val="4A5568"/>
+                </a:solidFill>
+                <a:latin typeface="Microsoft YaHei" pitchFamily="34" charset="0"/>
+                <a:ea typeface="Microsoft YaHei" pitchFamily="34" charset="-122"/>
+                <a:cs typeface="Microsoft YaHei" pitchFamily="34" charset="-120"/>
+              </a:rPr>
+              <a:t>× 7 号</a:t>
+            </a:r>
+            <a:endParaRPr lang="en-US" sz="900" dirty="0"/>
+          </a:p>
+        </p:txBody>
+      </p:sp>
+      <p:sp>
+        <p:nvSpPr>
+          <p:cNvPr id="57" name="Shape 55"/>
+          <p:cNvSpPr/>
+          <p:nvPr/>
+        </p:nvSpPr>
+        <p:spPr>
+          <a:xfrm>
+            <a:off x="6835140" y="3520440"/>
+            <a:ext cx="1165860" cy="457200"/>
+          </a:xfrm>
+          <a:prstGeom prst="rect">
+            <a:avLst/>
+          </a:prstGeom>
+          <a:solidFill>
+            <a:srgbClr val="FFFFFF"/>
+          </a:solidFill>
+          <a:ln w="6350">
+            <a:solidFill>
+              <a:srgbClr val="D4C5B9"/>
+            </a:solidFill>
+            <a:prstDash val="solid"/>
+          </a:ln>
+        </p:spPr>
+      </p:sp>
+      <p:sp>
+        <p:nvSpPr>
+          <p:cNvPr id="58" name="Text 56"/>
+          <p:cNvSpPr/>
+          <p:nvPr/>
+        </p:nvSpPr>
+        <p:spPr>
+          <a:xfrm>
+            <a:off x="6835140" y="3639312"/>
+            <a:ext cx="1165860" cy="228600"/>
+          </a:xfrm>
+          <a:prstGeom prst="rect">
+            <a:avLst/>
+          </a:prstGeom>
+          <a:noFill/>
+          <a:ln/>
+        </p:spPr>
+        <p:txBody>
+          <a:bodyPr wrap="square" rtlCol="0" anchor="ctr"/>
+          <a:lstStyle/>
+          <a:p>
+            <a:pPr algn="ctr" indent="0" marL="0">
+              <a:buNone/>
+            </a:pPr>
+            <a:r>
+              <a:rPr lang="en-US" sz="900" dirty="0">
+                <a:solidFill>
+                  <a:srgbClr val="4A5568"/>
+                </a:solidFill>
+                <a:latin typeface="Microsoft YaHei" pitchFamily="34" charset="0"/>
+                <a:ea typeface="Microsoft YaHei" pitchFamily="34" charset="-122"/>
+                <a:cs typeface="Microsoft YaHei" pitchFamily="34" charset="-120"/>
+              </a:rPr>
+              <a:t>× 9 号</a:t>
+            </a:r>
+            <a:endParaRPr lang="en-US" sz="900" dirty="0"/>
+          </a:p>
+        </p:txBody>
+      </p:sp>
+      <p:sp>
+        <p:nvSpPr>
+          <p:cNvPr id="59" name="Shape 57"/>
+          <p:cNvSpPr/>
+          <p:nvPr/>
+        </p:nvSpPr>
+        <p:spPr>
+          <a:xfrm>
+            <a:off x="8001000" y="3520440"/>
+            <a:ext cx="1165860" cy="457200"/>
+          </a:xfrm>
+          <a:prstGeom prst="rect">
+            <a:avLst/>
+          </a:prstGeom>
+          <a:solidFill>
+            <a:srgbClr val="FFFFFF"/>
+          </a:solidFill>
+          <a:ln w="6350">
+            <a:solidFill>
+              <a:srgbClr val="D4C5B9"/>
+            </a:solidFill>
+            <a:prstDash val="solid"/>
+          </a:ln>
+        </p:spPr>
+      </p:sp>
+      <p:sp>
+        <p:nvSpPr>
+          <p:cNvPr id="60" name="Text 58"/>
+          <p:cNvSpPr/>
+          <p:nvPr/>
+        </p:nvSpPr>
+        <p:spPr>
+          <a:xfrm>
+            <a:off x="8001000" y="3639312"/>
+            <a:ext cx="1165860" cy="228600"/>
+          </a:xfrm>
+          <a:prstGeom prst="rect">
+            <a:avLst/>
+          </a:prstGeom>
+          <a:noFill/>
+          <a:ln/>
+        </p:spPr>
+        <p:txBody>
+          <a:bodyPr wrap="square" rtlCol="0" anchor="ctr"/>
+          <a:lstStyle/>
+          <a:p>
+            <a:pPr algn="ctr" indent="0" marL="0">
+              <a:buNone/>
+            </a:pPr>
+            <a:r>
+              <a:rPr lang="en-US" sz="900" dirty="0">
+                <a:solidFill>
+                  <a:srgbClr val="4A5568"/>
+                </a:solidFill>
+                <a:latin typeface="Microsoft YaHei" pitchFamily="34" charset="0"/>
+                <a:ea typeface="Microsoft YaHei" pitchFamily="34" charset="-122"/>
+                <a:cs typeface="Microsoft YaHei" pitchFamily="34" charset="-120"/>
+              </a:rPr>
+              <a:t>× 3 号</a:t>
+            </a:r>
+            <a:endParaRPr lang="en-US" sz="900" dirty="0"/>
+          </a:p>
+        </p:txBody>
+      </p:sp>
+      <p:sp>
+        <p:nvSpPr>
+          <p:cNvPr id="61" name="Text 59"/>
+          <p:cNvSpPr/>
+          <p:nvPr/>
+        </p:nvSpPr>
+        <p:spPr>
+          <a:xfrm>
+            <a:off x="457200" y="4572000"/>
+            <a:ext cx="8229600" cy="365760"/>
+          </a:xfrm>
+          <a:prstGeom prst="rect">
+            <a:avLst/>
+          </a:prstGeom>
+          <a:noFill/>
+          <a:ln/>
+        </p:spPr>
+        <p:txBody>
+          <a:bodyPr wrap="square" rtlCol="0" anchor="ctr"/>
+          <a:lstStyle/>
+          <a:p>
+            <a:pPr algn="ctr" indent="0" marL="0">
+              <a:buNone/>
+            </a:pPr>
+            <a:r>
+              <a:rPr lang="en-US" sz="1100" i="1" dirty="0">
+                <a:solidFill>
+                  <a:srgbClr val="1A2238"/>
+                </a:solidFill>
+                <a:latin typeface="Microsoft YaHei" pitchFamily="34" charset="0"/>
+                <a:ea typeface="Microsoft YaHei" pitchFamily="34" charset="-122"/>
+                <a:cs typeface="Microsoft YaHei" pitchFamily="34" charset="-120"/>
+              </a:rPr>
+              <a:t>12 构型是本套件"主菜单" — 把 9 型 × 4 依恋 = 36 场景简化为 12, 临床定位更快</a:t>
+            </a:r>
+            <a:endParaRPr lang="en-US" sz="1100" dirty="0"/>
+          </a:p>
+        </p:txBody>
+      </p:sp>
+      <p:sp>
+        <p:nvSpPr>
+          <p:cNvPr id="62" name="Text 60"/>
+          <p:cNvSpPr/>
+          <p:nvPr/>
+        </p:nvSpPr>
+        <p:spPr>
+          <a:xfrm>
+            <a:off x="5943600" y="4892040"/>
+            <a:ext cx="2743200" cy="228600"/>
+          </a:xfrm>
+          <a:prstGeom prst="rect">
+            <a:avLst/>
+          </a:prstGeom>
+          <a:noFill/>
+          <a:ln/>
+        </p:spPr>
+        <p:txBody>
+          <a:bodyPr wrap="square" rtlCol="0" anchor="ctr"/>
+          <a:lstStyle/>
+          <a:p>
+            <a:pPr algn="r" indent="0" marL="0">
+              <a:buNone/>
+            </a:pPr>
+            <a:r>
+              <a:rPr lang="en-US" sz="900" dirty="0">
+                <a:solidFill>
+                  <a:srgbClr val="E2725B"/>
+                </a:solidFill>
+                <a:latin typeface="Microsoft YaHei" pitchFamily="34" charset="0"/>
+                <a:ea typeface="Microsoft YaHei" pitchFamily="34" charset="-122"/>
+                <a:cs typeface="Microsoft YaHei" pitchFamily="34" charset="-120"/>
+              </a:rPr>
+              <a:t>一念三轴 · Yiinian Triaxis (v2.2)</a:t>
+            </a:r>
+            <a:endParaRPr lang="en-US" sz="900" dirty="0"/>
           </a:p>
         </p:txBody>
       </p:sp>

</xml_diff>